<commit_message>
Implement approved visual design v3 and fix photo reorder
Match Refresco cover, department, and ficha slides in web preview plus PPTX/PDF export (cenefa, mascots, footer, no year on cover). Reorder ↑↓ in Preview now moves photos within a department. Bump app/APK to 1.3.0 for GitHub Pages and sideload sync.

Co-authored-by: jorgefausto0074-pc <jorgefausto0074-pc@users.noreply.github.com>
</commit_message>
<xml_diff>
--- a/samples/informe-ejemplo-alcolea.pptx
+++ b/samples/informe-ejemplo-alcolea.pptx
@@ -10,11 +10,9 @@
     <p:sldId id="258" r:id="rId4"/>
     <p:sldId id="259" r:id="rId5"/>
     <p:sldId id="260" r:id="rId6"/>
-    <p:sldId id="261" r:id="rId7"/>
-    <p:sldId id="262" r:id="rId8"/>
   </p:sldIdLst>
   <p:notesMasterIdLst>
-    <p:notesMasterId r:id="rId9"/>
+    <p:notesMasterId r:id="rId7"/>
   </p:notesMasterIdLst>
   <p:sldSz cx="12191695" cy="6858000"/>
   <p:notesSz cx="6858000" cy="12191695"/>
@@ -902,182 +900,6 @@
 </p:notes>
 </file>
 
-<file path=ppt/notesSlides/notesSlide6.xml><?xml version="1.0" encoding="utf-8"?>
-<p:notes xmlns:a="http://schemas.openxmlformats.org/drawingml/2006/main" xmlns:r="http://schemas.openxmlformats.org/officeDocument/2006/relationships" xmlns:p="http://schemas.openxmlformats.org/presentationml/2006/main">
-  <p:cSld>
-    <p:spTree>
-      <p:nvGrpSpPr>
-        <p:cNvPr id="1" name=""/>
-        <p:cNvGrpSpPr/>
-        <p:nvPr/>
-      </p:nvGrpSpPr>
-      <p:grpSpPr>
-        <a:xfrm>
-          <a:off x="0" y="0"/>
-          <a:ext cx="0" cy="0"/>
-          <a:chOff x="0" y="0"/>
-          <a:chExt cx="0" cy="0"/>
-        </a:xfrm>
-      </p:grpSpPr>
-      <p:sp>
-        <p:nvSpPr>
-          <p:cNvPr id="2" name="Slide Image Placeholder 1"/>
-          <p:cNvSpPr>
-            <a:spLocks noGrp="1" noRot="1" noChangeAspect="1"/>
-          </p:cNvSpPr>
-          <p:nvPr>
-            <p:ph type="sldImg"/>
-          </p:nvPr>
-        </p:nvSpPr>
-        <p:spPr/>
-      </p:sp>
-      <p:sp>
-        <p:nvSpPr>
-          <p:cNvPr id="3" name="Notes Placeholder 2"/>
-          <p:cNvSpPr>
-            <a:spLocks noGrp="1"/>
-          </p:cNvSpPr>
-          <p:nvPr>
-            <p:ph type="body" idx="1"/>
-          </p:nvPr>
-        </p:nvSpPr>
-        <p:spPr/>
-        <p:txBody>
-          <a:bodyPr/>
-          <a:lstStyle/>
-          <a:p>
-            <a:r>
-              <a:rPr lang="en-US" dirty="0"/>
-              <a:t/>
-            </a:r>
-            <a:endParaRPr lang="en-US" dirty="0"/>
-          </a:p>
-        </p:txBody>
-      </p:sp>
-      <p:sp>
-        <p:nvSpPr>
-          <p:cNvPr id="4" name="Slide Number Placeholder 3"/>
-          <p:cNvSpPr>
-            <a:spLocks noGrp="1"/>
-          </p:cNvSpPr>
-          <p:nvPr>
-            <p:ph type="sldNum" sz="quarter" idx="10"/>
-          </p:nvPr>
-        </p:nvSpPr>
-        <p:spPr/>
-        <p:txBody>
-          <a:bodyPr/>
-          <a:lstStyle/>
-          <a:p>
-            <a:fld id="{F7021451-1387-4CA6-816F-3879F97B5CBC}" type="slidenum">
-              <a:rPr lang="en-US"/>
-              <a:t>6</a:t>
-            </a:fld>
-            <a:endParaRPr lang="en-US"/>
-          </a:p>
-        </p:txBody>
-      </p:sp>
-    </p:spTree>
-    <p:extLst>
-      <p:ext uri="{BB962C8B-B14F-4D97-AF65-F5344CB8AC3E}">
-        <p14:creationId xmlns:p14="http://schemas.microsoft.com/office/powerpoint/2010/main" val="1024086991"/>
-      </p:ext>
-    </p:extLst>
-  </p:cSld>
-  <p:clrMapOvr>
-    <a:masterClrMapping/>
-  </p:clrMapOvr>
-</p:notes>
-</file>
-
-<file path=ppt/notesSlides/notesSlide7.xml><?xml version="1.0" encoding="utf-8"?>
-<p:notes xmlns:a="http://schemas.openxmlformats.org/drawingml/2006/main" xmlns:r="http://schemas.openxmlformats.org/officeDocument/2006/relationships" xmlns:p="http://schemas.openxmlformats.org/presentationml/2006/main">
-  <p:cSld>
-    <p:spTree>
-      <p:nvGrpSpPr>
-        <p:cNvPr id="1" name=""/>
-        <p:cNvGrpSpPr/>
-        <p:nvPr/>
-      </p:nvGrpSpPr>
-      <p:grpSpPr>
-        <a:xfrm>
-          <a:off x="0" y="0"/>
-          <a:ext cx="0" cy="0"/>
-          <a:chOff x="0" y="0"/>
-          <a:chExt cx="0" cy="0"/>
-        </a:xfrm>
-      </p:grpSpPr>
-      <p:sp>
-        <p:nvSpPr>
-          <p:cNvPr id="2" name="Slide Image Placeholder 1"/>
-          <p:cNvSpPr>
-            <a:spLocks noGrp="1" noRot="1" noChangeAspect="1"/>
-          </p:cNvSpPr>
-          <p:nvPr>
-            <p:ph type="sldImg"/>
-          </p:nvPr>
-        </p:nvSpPr>
-        <p:spPr/>
-      </p:sp>
-      <p:sp>
-        <p:nvSpPr>
-          <p:cNvPr id="3" name="Notes Placeholder 2"/>
-          <p:cNvSpPr>
-            <a:spLocks noGrp="1"/>
-          </p:cNvSpPr>
-          <p:nvPr>
-            <p:ph type="body" idx="1"/>
-          </p:nvPr>
-        </p:nvSpPr>
-        <p:spPr/>
-        <p:txBody>
-          <a:bodyPr/>
-          <a:lstStyle/>
-          <a:p>
-            <a:r>
-              <a:rPr lang="en-US" dirty="0"/>
-              <a:t/>
-            </a:r>
-            <a:endParaRPr lang="en-US" dirty="0"/>
-          </a:p>
-        </p:txBody>
-      </p:sp>
-      <p:sp>
-        <p:nvSpPr>
-          <p:cNvPr id="4" name="Slide Number Placeholder 3"/>
-          <p:cNvSpPr>
-            <a:spLocks noGrp="1"/>
-          </p:cNvSpPr>
-          <p:nvPr>
-            <p:ph type="sldNum" sz="quarter" idx="10"/>
-          </p:nvPr>
-        </p:nvSpPr>
-        <p:spPr/>
-        <p:txBody>
-          <a:bodyPr/>
-          <a:lstStyle/>
-          <a:p>
-            <a:fld id="{F7021451-1387-4CA6-816F-3879F97B5CBC}" type="slidenum">
-              <a:rPr lang="en-US"/>
-              <a:t>7</a:t>
-            </a:fld>
-            <a:endParaRPr lang="en-US"/>
-          </a:p>
-        </p:txBody>
-      </p:sp>
-    </p:spTree>
-    <p:extLst>
-      <p:ext uri="{BB962C8B-B14F-4D97-AF65-F5344CB8AC3E}">
-        <p14:creationId xmlns:p14="http://schemas.microsoft.com/office/powerpoint/2010/main" val="1024086991"/>
-      </p:ext>
-    </p:extLst>
-  </p:cSld>
-  <p:clrMapOvr>
-    <a:masterClrMapping/>
-  </p:clrMapOvr>
-</p:notes>
-</file>
-
 <file path=ppt/slideLayouts/slideLayout1.xml><?xml version="1.0" encoding="utf-8"?>
 <p:sldLayout xmlns:a="http://schemas.openxmlformats.org/drawingml/2006/main" xmlns:r="http://schemas.openxmlformats.org/officeDocument/2006/relationships" xmlns:p="http://schemas.openxmlformats.org/presentationml/2006/main" preserve="1">
   <p:cSld name="DEFAULT">
@@ -1388,6 +1210,13 @@
 <file path=ppt/slides/slide1.xml><?xml version="1.0" encoding="utf-8"?>
 <p:sld xmlns:a="http://schemas.openxmlformats.org/drawingml/2006/main" xmlns:r="http://schemas.openxmlformats.org/officeDocument/2006/relationships" xmlns:p="http://schemas.openxmlformats.org/presentationml/2006/main">
   <p:cSld name="Slide 1">
+    <p:bg>
+      <p:bgPr>
+        <a:solidFill>
+          <a:srgbClr val="FAFCFA"/>
+        </a:solidFill>
+      </p:bgPr>
+    </p:bg>
     <p:spTree>
       <p:nvGrpSpPr>
         <p:cNvPr id="1" name=""/>
@@ -1404,14 +1233,154 @@
       </p:grpSpPr>
       <p:sp>
         <p:nvSpPr>
-          <p:cNvPr id="2" name="Text 0"/>
-          <p:cNvSpPr/>
-          <p:nvPr/>
-        </p:nvSpPr>
-        <p:spPr>
-          <a:xfrm>
-            <a:off x="1527048" y="1554480"/>
-            <a:ext cx="9144000" cy="1463040"/>
+          <p:cNvPr id="2" name="Shape 0"/>
+          <p:cNvSpPr/>
+          <p:nvPr/>
+        </p:nvSpPr>
+        <p:spPr>
+          <a:xfrm>
+            <a:off x="9646920" y="45720"/>
+            <a:ext cx="3246120" cy="3246120"/>
+          </a:xfrm>
+          <a:prstGeom prst="ellipse">
+            <a:avLst/>
+          </a:prstGeom>
+          <a:solidFill>
+            <a:srgbClr val="03A64B"/>
+          </a:solidFill>
+          <a:ln w="12700">
+            <a:solidFill>
+              <a:srgbClr val="FFFFFF">
+                <a:alpha val="0"/>
+              </a:srgbClr>
+            </a:solidFill>
+            <a:prstDash val="solid"/>
+          </a:ln>
+        </p:spPr>
+      </p:sp>
+      <p:sp>
+        <p:nvSpPr>
+          <p:cNvPr id="3" name="Shape 1"/>
+          <p:cNvSpPr/>
+          <p:nvPr/>
+        </p:nvSpPr>
+        <p:spPr>
+          <a:xfrm>
+            <a:off x="9189720" y="2212848"/>
+            <a:ext cx="1783080" cy="1783080"/>
+          </a:xfrm>
+          <a:prstGeom prst="ellipse">
+            <a:avLst/>
+          </a:prstGeom>
+          <a:solidFill>
+            <a:srgbClr val="E8922A"/>
+          </a:solidFill>
+          <a:ln w="12700">
+            <a:solidFill>
+              <a:srgbClr val="FFFFFF">
+                <a:alpha val="0"/>
+              </a:srgbClr>
+            </a:solidFill>
+            <a:prstDash val="solid"/>
+          </a:ln>
+        </p:spPr>
+      </p:sp>
+      <p:sp>
+        <p:nvSpPr>
+          <p:cNvPr id="4" name="Shape 2"/>
+          <p:cNvSpPr/>
+          <p:nvPr/>
+        </p:nvSpPr>
+        <p:spPr>
+          <a:xfrm>
+            <a:off x="11018520" y="3127248"/>
+            <a:ext cx="1261872" cy="1261872"/>
+          </a:xfrm>
+          <a:prstGeom prst="ellipse">
+            <a:avLst/>
+          </a:prstGeom>
+          <a:solidFill>
+            <a:srgbClr val="F3FBF6"/>
+          </a:solidFill>
+          <a:ln w="12700">
+            <a:solidFill>
+              <a:srgbClr val="FFFFFF">
+                <a:alpha val="0"/>
+              </a:srgbClr>
+            </a:solidFill>
+            <a:prstDash val="solid"/>
+          </a:ln>
+        </p:spPr>
+      </p:sp>
+      <p:sp>
+        <p:nvSpPr>
+          <p:cNvPr id="5" name="Shape 3"/>
+          <p:cNvSpPr/>
+          <p:nvPr/>
+        </p:nvSpPr>
+        <p:spPr>
+          <a:xfrm>
+            <a:off x="713232" y="960120"/>
+            <a:ext cx="2331720" cy="1481328"/>
+          </a:xfrm>
+          <a:prstGeom prst="roundRect">
+            <a:avLst>
+              <a:gd name="adj" fmla="val 7407"/>
+            </a:avLst>
+          </a:prstGeom>
+          <a:solidFill>
+            <a:srgbClr val="FFFFFF"/>
+          </a:solidFill>
+          <a:ln w="12700">
+            <a:solidFill>
+              <a:srgbClr val="FFFFFF">
+                <a:alpha val="0"/>
+              </a:srgbClr>
+            </a:solidFill>
+            <a:prstDash val="solid"/>
+          </a:ln>
+          <a:effectLst>
+            <a:outerShdw sx="100000" sy="100000" kx="0" ky="0" algn="bl" rotWithShape="0" blurRad="127000" dist="38100" dir="16200000">
+              <a:srgbClr val="2F3E46">
+                <a:alpha val="12000"/>
+              </a:srgbClr>
+            </a:outerShdw>
+          </a:effectLst>
+        </p:spPr>
+      </p:sp>
+      <p:pic>
+        <p:nvPicPr>
+          <p:cNvPr id="6" name="Image 0" descr="preencoded.png">    </p:cNvPr>
+          <p:cNvPicPr>
+            <a:picLocks noChangeAspect="1"/>
+          </p:cNvPicPr>
+          <p:nvPr/>
+        </p:nvPicPr>
+        <p:blipFill>
+          <a:blip r:embed="rId1"/>
+          <a:srcRect l="0" r="0" t="0" b="0"/>
+          <a:stretch/>
+        </p:blipFill>
+        <p:spPr>
+          <a:xfrm>
+            <a:off x="1190695" y="1280160"/>
+            <a:ext cx="1376793" cy="841248"/>
+          </a:xfrm>
+          <a:prstGeom prst="rect">
+            <a:avLst/>
+          </a:prstGeom>
+        </p:spPr>
+      </p:pic>
+      <p:sp>
+        <p:nvSpPr>
+          <p:cNvPr id="7" name="Text 4"/>
+          <p:cNvSpPr/>
+          <p:nvPr/>
+        </p:nvSpPr>
+        <p:spPr>
+          <a:xfrm>
+            <a:off x="713232" y="2578608"/>
+            <a:ext cx="6766560" cy="256032"/>
           </a:xfrm>
           <a:prstGeom prst="rect">
             <a:avLst/>
@@ -1420,37 +1389,37 @@
           <a:ln/>
         </p:spPr>
         <p:txBody>
-          <a:bodyPr wrap="square" rtlCol="0" anchor="ctr"/>
-          <a:lstStyle/>
-          <a:p>
-            <a:pPr algn="ctr" indent="0" marL="0">
+          <a:bodyPr wrap="square" lIns="0" tIns="0" rIns="0" bIns="0" rtlCol="0" anchor="ctr"/>
+          <a:lstStyle/>
+          <a:p>
+            <a:pPr indent="0" marL="0">
               <a:buNone/>
             </a:pPr>
             <a:r>
-              <a:rPr lang="en-US" sz="3600" b="1" dirty="0">
+              <a:rPr lang="en-US" sz="1100" b="1" spc="300" kern="0" dirty="0">
                 <a:solidFill>
-                  <a:srgbClr val="000000"/>
+                  <a:srgbClr val="D9871A"/>
                 </a:solidFill>
                 <a:latin typeface="Calibri" pitchFamily="34" charset="0"/>
                 <a:ea typeface="Calibri" pitchFamily="34" charset="-122"/>
                 <a:cs typeface="Calibri" pitchFamily="34" charset="-120"/>
               </a:rPr>
-              <a:t>INSPECCION INCIDENCIAS CALIDAD 2026</a:t>
-            </a:r>
-            <a:endParaRPr lang="en-US" sz="3600" dirty="0"/>
-          </a:p>
-        </p:txBody>
-      </p:sp>
-      <p:sp>
-        <p:nvSpPr>
-          <p:cNvPr id="3" name="Text 1"/>
-          <p:cNvSpPr/>
-          <p:nvPr/>
-        </p:nvSpPr>
-        <p:spPr>
-          <a:xfrm>
-            <a:off x="1527048" y="4023360"/>
-            <a:ext cx="9144000" cy="914400"/>
+              <a:t>CALIDAD · PLANTA ALCOLEA</a:t>
+            </a:r>
+            <a:endParaRPr lang="en-US" sz="1100" dirty="0"/>
+          </a:p>
+        </p:txBody>
+      </p:sp>
+      <p:sp>
+        <p:nvSpPr>
+          <p:cNvPr id="8" name="Text 5"/>
+          <p:cNvSpPr/>
+          <p:nvPr/>
+        </p:nvSpPr>
+        <p:spPr>
+          <a:xfrm>
+            <a:off x="713232" y="2852928"/>
+            <a:ext cx="6949440" cy="1234440"/>
           </a:xfrm>
           <a:prstGeom prst="rect">
             <a:avLst/>
@@ -1459,16 +1428,55 @@
           <a:ln/>
         </p:spPr>
         <p:txBody>
-          <a:bodyPr wrap="square" rtlCol="0" anchor="ctr"/>
-          <a:lstStyle/>
-          <a:p>
-            <a:pPr algn="ctr" indent="0" marL="0">
+          <a:bodyPr wrap="square" lIns="0" tIns="0" rIns="0" bIns="0" rtlCol="0" anchor="t"/>
+          <a:lstStyle/>
+          <a:p>
+            <a:pPr algn="l" indent="0" marL="0">
               <a:buNone/>
             </a:pPr>
             <a:r>
-              <a:rPr lang="en-US" sz="1800" b="1" dirty="0">
+              <a:rPr lang="en-US" sz="2800" b="1" dirty="0">
                 <a:solidFill>
-                  <a:srgbClr val="000000"/>
+                  <a:srgbClr val="03A64B"/>
+                </a:solidFill>
+                <a:latin typeface="Calibri" pitchFamily="34" charset="0"/>
+                <a:ea typeface="Calibri" pitchFamily="34" charset="-122"/>
+                <a:cs typeface="Calibri" pitchFamily="34" charset="-120"/>
+              </a:rPr>
+              <a:t>INSPECCION INCIDENCIAS CALIDAD</a:t>
+            </a:r>
+            <a:endParaRPr lang="en-US" sz="2800" dirty="0"/>
+          </a:p>
+        </p:txBody>
+      </p:sp>
+      <p:sp>
+        <p:nvSpPr>
+          <p:cNvPr id="9" name="Text 6"/>
+          <p:cNvSpPr/>
+          <p:nvPr/>
+        </p:nvSpPr>
+        <p:spPr>
+          <a:xfrm>
+            <a:off x="713232" y="4133088"/>
+            <a:ext cx="7498080" cy="347472"/>
+          </a:xfrm>
+          <a:prstGeom prst="rect">
+            <a:avLst/>
+          </a:prstGeom>
+          <a:noFill/>
+          <a:ln/>
+        </p:spPr>
+        <p:txBody>
+          <a:bodyPr wrap="square" lIns="0" tIns="0" rIns="0" bIns="0" rtlCol="0" anchor="ctr"/>
+          <a:lstStyle/>
+          <a:p>
+            <a:pPr indent="0" marL="0">
+              <a:buNone/>
+            </a:pPr>
+            <a:r>
+              <a:rPr lang="en-US" sz="1300" b="1" dirty="0">
+                <a:solidFill>
+                  <a:srgbClr val="2F3E46"/>
                 </a:solidFill>
                 <a:latin typeface="Calibri" pitchFamily="34" charset="0"/>
                 <a:ea typeface="Calibri" pitchFamily="34" charset="-122"/>
@@ -1476,70 +1484,136 @@
               </a:rPr>
               <a:t>REFRESCO IBERIA PLANTA ALCOLEA</a:t>
             </a:r>
-            <a:endParaRPr lang="en-US" sz="1800" dirty="0"/>
-          </a:p>
-        </p:txBody>
-      </p:sp>
-      <p:sp>
-        <p:nvSpPr>
-          <p:cNvPr id="4" name="Text 2"/>
-          <p:cNvSpPr/>
-          <p:nvPr/>
-        </p:nvSpPr>
-        <p:spPr>
-          <a:xfrm>
-            <a:off x="1527048" y="5029200"/>
-            <a:ext cx="9144000" cy="365760"/>
-          </a:xfrm>
-          <a:prstGeom prst="rect">
-            <a:avLst/>
-          </a:prstGeom>
-          <a:noFill/>
-          <a:ln/>
-        </p:spPr>
-        <p:txBody>
-          <a:bodyPr wrap="square" rtlCol="0" anchor="ctr"/>
-          <a:lstStyle/>
-          <a:p>
-            <a:pPr algn="ctr" indent="0" marL="0">
-              <a:buNone/>
-            </a:pPr>
-            <a:r>
-              <a:rPr lang="en-US" sz="1200" b="1" dirty="0">
-                <a:solidFill>
-                  <a:srgbClr val="C00000"/>
-                </a:solidFill>
-              </a:rPr>
-              <a:t>EJEMPLO — DATOS DE DEMOSTRACIÓN (NO REALES)</a:t>
-            </a:r>
-            <a:endParaRPr lang="en-US" sz="1200" dirty="0"/>
+            <a:endParaRPr lang="en-US" sz="1300" dirty="0"/>
           </a:p>
         </p:txBody>
       </p:sp>
       <p:pic>
         <p:nvPicPr>
-          <p:cNvPr id="5" name="Image 0" descr="/workspace/inspecciones-calidad/app/public/assets/logo-diamante.png">    </p:cNvPr>
+          <p:cNvPr id="10" name="Image 1" descr="preencoded.png">    </p:cNvPr>
           <p:cNvPicPr>
             <a:picLocks noChangeAspect="1"/>
           </p:cNvPicPr>
           <p:nvPr/>
         </p:nvPicPr>
         <p:blipFill>
-          <a:blip r:embed="rId1"/>
+          <a:blip r:embed="rId2"/>
           <a:stretch>
             <a:fillRect/>
           </a:stretch>
         </p:blipFill>
         <p:spPr>
           <a:xfrm>
-            <a:off x="9418320" y="3566160"/>
-            <a:ext cx="2148840" cy="2148840"/>
+            <a:off x="0" y="5333695"/>
+            <a:ext cx="12191695" cy="1524305"/>
           </a:xfrm>
           <a:prstGeom prst="rect">
             <a:avLst/>
           </a:prstGeom>
         </p:spPr>
       </p:pic>
+      <p:pic>
+        <p:nvPicPr>
+          <p:cNvPr id="11" name="Image 2" descr="preencoded.png">    </p:cNvPr>
+          <p:cNvPicPr>
+            <a:picLocks noChangeAspect="1"/>
+          </p:cNvPicPr>
+          <p:nvPr/>
+        </p:nvPicPr>
+        <p:blipFill>
+          <a:blip r:embed="rId3"/>
+          <a:stretch>
+            <a:fillRect/>
+          </a:stretch>
+        </p:blipFill>
+        <p:spPr>
+          <a:xfrm>
+            <a:off x="256032" y="5596128"/>
+            <a:ext cx="1024128" cy="1207008"/>
+          </a:xfrm>
+          <a:prstGeom prst="rect">
+            <a:avLst/>
+          </a:prstGeom>
+        </p:spPr>
+      </p:pic>
+      <p:sp>
+        <p:nvSpPr>
+          <p:cNvPr id="12" name="Text 7"/>
+          <p:cNvSpPr/>
+          <p:nvPr/>
+        </p:nvSpPr>
+        <p:spPr>
+          <a:xfrm>
+            <a:off x="1389888" y="6473952"/>
+            <a:ext cx="7589520" cy="256032"/>
+          </a:xfrm>
+          <a:prstGeom prst="rect">
+            <a:avLst/>
+          </a:prstGeom>
+          <a:noFill/>
+          <a:ln/>
+        </p:spPr>
+        <p:txBody>
+          <a:bodyPr wrap="square" lIns="0" tIns="0" rIns="0" bIns="0" rtlCol="0" anchor="ctr"/>
+          <a:lstStyle/>
+          <a:p>
+            <a:pPr indent="0" marL="0">
+              <a:buNone/>
+            </a:pPr>
+            <a:r>
+              <a:rPr lang="en-US" sz="1000" b="1" dirty="0">
+                <a:solidFill>
+                  <a:srgbClr val="FFFFFF"/>
+                </a:solidFill>
+                <a:latin typeface="Calibri" pitchFamily="34" charset="0"/>
+                <a:ea typeface="Calibri" pitchFamily="34" charset="-122"/>
+                <a:cs typeface="Calibri" pitchFamily="34" charset="-120"/>
+              </a:rPr>
+              <a:t>Inspecciones calidad · Refresco Iberia · Planta Alcolea</a:t>
+            </a:r>
+            <a:endParaRPr lang="en-US" sz="1000" dirty="0"/>
+          </a:p>
+        </p:txBody>
+      </p:sp>
+      <p:sp>
+        <p:nvSpPr>
+          <p:cNvPr id="13" name="Text 8"/>
+          <p:cNvSpPr/>
+          <p:nvPr/>
+        </p:nvSpPr>
+        <p:spPr>
+          <a:xfrm>
+            <a:off x="9281160" y="6364224"/>
+            <a:ext cx="2651760" cy="384048"/>
+          </a:xfrm>
+          <a:prstGeom prst="rect">
+            <a:avLst/>
+          </a:prstGeom>
+          <a:noFill/>
+          <a:ln/>
+        </p:spPr>
+        <p:txBody>
+          <a:bodyPr wrap="square" lIns="0" tIns="0" rIns="0" bIns="0" rtlCol="0" anchor="ctr"/>
+          <a:lstStyle/>
+          <a:p>
+            <a:pPr algn="r" indent="0" marL="0">
+              <a:buNone/>
+            </a:pPr>
+            <a:r>
+              <a:rPr lang="en-US" sz="1800" b="1" dirty="0">
+                <a:solidFill>
+                  <a:srgbClr val="FFFFFF"/>
+                </a:solidFill>
+                <a:latin typeface="Calibri" pitchFamily="34" charset="0"/>
+                <a:ea typeface="Calibri" pitchFamily="34" charset="-122"/>
+                <a:cs typeface="Calibri" pitchFamily="34" charset="-120"/>
+              </a:rPr>
+              <a:t>Refresco</a:t>
+            </a:r>
+            <a:endParaRPr lang="en-US" sz="1800" dirty="0"/>
+          </a:p>
+        </p:txBody>
+      </p:sp>
     </p:spTree>
   </p:cSld>
   <p:clrMapOvr>
@@ -1551,6 +1625,13 @@
 <file path=ppt/slides/slide2.xml><?xml version="1.0" encoding="utf-8"?>
 <p:sld xmlns:a="http://schemas.openxmlformats.org/drawingml/2006/main" xmlns:r="http://schemas.openxmlformats.org/officeDocument/2006/relationships" xmlns:p="http://schemas.openxmlformats.org/presentationml/2006/main">
   <p:cSld name="Slide 2">
+    <p:bg>
+      <p:bgPr>
+        <a:solidFill>
+          <a:srgbClr val="FAFCFA"/>
+        </a:solidFill>
+      </p:bgPr>
+    </p:bg>
     <p:spTree>
       <p:nvGrpSpPr>
         <p:cNvPr id="1" name=""/>
@@ -1567,14 +1648,68 @@
       </p:grpSpPr>
       <p:sp>
         <p:nvSpPr>
-          <p:cNvPr id="2" name="Text 0"/>
-          <p:cNvSpPr/>
-          <p:nvPr/>
-        </p:nvSpPr>
-        <p:spPr>
-          <a:xfrm>
-            <a:off x="457200" y="2560320"/>
-            <a:ext cx="11277295" cy="1097280"/>
+          <p:cNvPr id="2" name="Shape 0"/>
+          <p:cNvSpPr/>
+          <p:nvPr/>
+        </p:nvSpPr>
+        <p:spPr>
+          <a:xfrm>
+            <a:off x="-777240" y="1874520"/>
+            <a:ext cx="2148840" cy="2148840"/>
+          </a:xfrm>
+          <a:prstGeom prst="ellipse">
+            <a:avLst/>
+          </a:prstGeom>
+          <a:solidFill>
+            <a:srgbClr val="F0E4D0"/>
+          </a:solidFill>
+          <a:ln w="12700">
+            <a:solidFill>
+              <a:srgbClr val="FFFFFF">
+                <a:alpha val="0"/>
+              </a:srgbClr>
+            </a:solidFill>
+            <a:prstDash val="solid"/>
+          </a:ln>
+        </p:spPr>
+      </p:sp>
+      <p:sp>
+        <p:nvSpPr>
+          <p:cNvPr id="3" name="Shape 1"/>
+          <p:cNvSpPr/>
+          <p:nvPr/>
+        </p:nvSpPr>
+        <p:spPr>
+          <a:xfrm>
+            <a:off x="10561320" y="-320040"/>
+            <a:ext cx="2606040" cy="2606040"/>
+          </a:xfrm>
+          <a:prstGeom prst="ellipse">
+            <a:avLst/>
+          </a:prstGeom>
+          <a:solidFill>
+            <a:srgbClr val="D8F3E3"/>
+          </a:solidFill>
+          <a:ln w="12700">
+            <a:solidFill>
+              <a:srgbClr val="FFFFFF">
+                <a:alpha val="0"/>
+              </a:srgbClr>
+            </a:solidFill>
+            <a:prstDash val="solid"/>
+          </a:ln>
+        </p:spPr>
+      </p:sp>
+      <p:sp>
+        <p:nvSpPr>
+          <p:cNvPr id="4" name="Text 2"/>
+          <p:cNvSpPr/>
+          <p:nvPr/>
+        </p:nvSpPr>
+        <p:spPr>
+          <a:xfrm>
+            <a:off x="731520" y="2084832"/>
+            <a:ext cx="10725912" cy="292608"/>
           </a:xfrm>
           <a:prstGeom prst="rect">
             <a:avLst/>
@@ -1583,16 +1718,94 @@
           <a:ln/>
         </p:spPr>
         <p:txBody>
-          <a:bodyPr wrap="square" rtlCol="0" anchor="ctr"/>
+          <a:bodyPr wrap="square" lIns="0" tIns="0" rIns="0" bIns="0" rtlCol="0" anchor="ctr"/>
           <a:lstStyle/>
           <a:p>
             <a:pPr algn="ctr" indent="0" marL="0">
               <a:buNone/>
             </a:pPr>
             <a:r>
-              <a:rPr lang="en-US" sz="3600" b="1" dirty="0">
+              <a:rPr lang="en-US" sz="1200" b="1" spc="400" kern="0" dirty="0">
                 <a:solidFill>
-                  <a:srgbClr val="1F4E79"/>
+                  <a:srgbClr val="D9871A"/>
+                </a:solidFill>
+                <a:latin typeface="Calibri" pitchFamily="34" charset="0"/>
+                <a:ea typeface="Calibri" pitchFamily="34" charset="-122"/>
+                <a:cs typeface="Calibri" pitchFamily="34" charset="-120"/>
+              </a:rPr>
+              <a:t>DEPARTAMENTO</a:t>
+            </a:r>
+            <a:endParaRPr lang="en-US" sz="1200" dirty="0"/>
+          </a:p>
+        </p:txBody>
+      </p:sp>
+      <p:sp>
+        <p:nvSpPr>
+          <p:cNvPr id="5" name="Text 3"/>
+          <p:cNvSpPr/>
+          <p:nvPr/>
+        </p:nvSpPr>
+        <p:spPr>
+          <a:xfrm>
+            <a:off x="731520" y="2359152"/>
+            <a:ext cx="10725912" cy="777240"/>
+          </a:xfrm>
+          <a:prstGeom prst="rect">
+            <a:avLst/>
+          </a:prstGeom>
+          <a:noFill/>
+          <a:ln/>
+        </p:spPr>
+        <p:txBody>
+          <a:bodyPr wrap="square" lIns="0" tIns="0" rIns="0" bIns="0" rtlCol="0" anchor="ctr"/>
+          <a:lstStyle/>
+          <a:p>
+            <a:pPr algn="ctr" indent="0" marL="0">
+              <a:buNone/>
+            </a:pPr>
+            <a:r>
+              <a:rPr lang="en-US" sz="4400" b="1" dirty="0">
+                <a:solidFill>
+                  <a:srgbClr val="D9871A"/>
+                </a:solidFill>
+                <a:latin typeface="Calibri" pitchFamily="34" charset="0"/>
+                <a:ea typeface="Calibri" pitchFamily="34" charset="-122"/>
+                <a:cs typeface="Calibri" pitchFamily="34" charset="-120"/>
+              </a:rPr>
+              <a:t>EXTERIORES</a:t>
+            </a:r>
+            <a:endParaRPr lang="en-US" sz="4400" dirty="0"/>
+          </a:p>
+        </p:txBody>
+      </p:sp>
+      <p:sp>
+        <p:nvSpPr>
+          <p:cNvPr id="6" name="Text 4"/>
+          <p:cNvSpPr/>
+          <p:nvPr/>
+        </p:nvSpPr>
+        <p:spPr>
+          <a:xfrm>
+            <a:off x="731520" y="3182112"/>
+            <a:ext cx="10725912" cy="640080"/>
+          </a:xfrm>
+          <a:prstGeom prst="rect">
+            <a:avLst/>
+          </a:prstGeom>
+          <a:noFill/>
+          <a:ln/>
+        </p:spPr>
+        <p:txBody>
+          <a:bodyPr wrap="square" lIns="0" tIns="0" rIns="0" bIns="0" rtlCol="0" anchor="ctr"/>
+          <a:lstStyle/>
+          <a:p>
+            <a:pPr algn="ctr" indent="0" marL="0">
+              <a:buNone/>
+            </a:pPr>
+            <a:r>
+              <a:rPr lang="en-US" sz="2400" b="1" dirty="0">
+                <a:solidFill>
+                  <a:srgbClr val="03A64B"/>
                 </a:solidFill>
                 <a:latin typeface="Calibri" pitchFamily="34" charset="0"/>
                 <a:ea typeface="Calibri" pitchFamily="34" charset="-122"/>
@@ -1600,29 +1813,174 @@
               </a:rPr>
               <a:t>INCIDENCIAS EXTERIORES</a:t>
             </a:r>
-            <a:endParaRPr lang="en-US" sz="3600" dirty="0"/>
-          </a:p>
-        </p:txBody>
-      </p:sp>
-      <p:sp>
-        <p:nvSpPr>
-          <p:cNvPr id="3" name="Shape 1"/>
-          <p:cNvSpPr/>
-          <p:nvPr/>
-        </p:nvSpPr>
-        <p:spPr>
-          <a:xfrm>
-            <a:off x="4114800" y="3749040"/>
-            <a:ext cx="3931920" cy="73152"/>
-          </a:xfrm>
-          <a:prstGeom prst="rect">
-            <a:avLst/>
-          </a:prstGeom>
-          <a:solidFill>
-            <a:srgbClr val="FFC000"/>
-          </a:solidFill>
+            <a:endParaRPr lang="en-US" sz="2400" dirty="0"/>
+          </a:p>
+        </p:txBody>
+      </p:sp>
+      <p:pic>
+        <p:nvPicPr>
+          <p:cNvPr id="7" name="Image 0" descr="preencoded.png">    </p:cNvPr>
+          <p:cNvPicPr>
+            <a:picLocks noChangeAspect="1"/>
+          </p:cNvPicPr>
+          <p:nvPr/>
+        </p:nvPicPr>
+        <p:blipFill>
+          <a:blip r:embed="rId1"/>
+          <a:stretch>
+            <a:fillRect/>
+          </a:stretch>
+        </p:blipFill>
+        <p:spPr>
+          <a:xfrm>
+            <a:off x="0" y="5333695"/>
+            <a:ext cx="12191695" cy="1524305"/>
+          </a:xfrm>
+          <a:prstGeom prst="rect">
+            <a:avLst/>
+          </a:prstGeom>
+        </p:spPr>
+      </p:pic>
+      <p:pic>
+        <p:nvPicPr>
+          <p:cNvPr id="8" name="Image 1" descr="preencoded.png">    </p:cNvPr>
+          <p:cNvPicPr>
+            <a:picLocks noChangeAspect="1"/>
+          </p:cNvPicPr>
+          <p:nvPr/>
+        </p:nvPicPr>
+        <p:blipFill>
+          <a:blip r:embed="rId2"/>
+          <a:stretch>
+            <a:fillRect/>
+          </a:stretch>
+        </p:blipFill>
+        <p:spPr>
+          <a:xfrm>
+            <a:off x="256032" y="5596128"/>
+            <a:ext cx="1024128" cy="1207008"/>
+          </a:xfrm>
+          <a:prstGeom prst="rect">
+            <a:avLst/>
+          </a:prstGeom>
+        </p:spPr>
+      </p:pic>
+      <p:sp>
+        <p:nvSpPr>
+          <p:cNvPr id="9" name="Text 5"/>
+          <p:cNvSpPr/>
+          <p:nvPr/>
+        </p:nvSpPr>
+        <p:spPr>
+          <a:xfrm>
+            <a:off x="1389888" y="6473952"/>
+            <a:ext cx="7589520" cy="256032"/>
+          </a:xfrm>
+          <a:prstGeom prst="rect">
+            <a:avLst/>
+          </a:prstGeom>
+          <a:noFill/>
           <a:ln/>
         </p:spPr>
+        <p:txBody>
+          <a:bodyPr wrap="square" lIns="0" tIns="0" rIns="0" bIns="0" rtlCol="0" anchor="ctr"/>
+          <a:lstStyle/>
+          <a:p>
+            <a:pPr indent="0" marL="0">
+              <a:buNone/>
+            </a:pPr>
+            <a:r>
+              <a:rPr lang="en-US" sz="1000" b="1" dirty="0">
+                <a:solidFill>
+                  <a:srgbClr val="FFFFFF"/>
+                </a:solidFill>
+                <a:latin typeface="Calibri" pitchFamily="34" charset="0"/>
+                <a:ea typeface="Calibri" pitchFamily="34" charset="-122"/>
+                <a:cs typeface="Calibri" pitchFamily="34" charset="-120"/>
+              </a:rPr>
+              <a:t>Inspecciones calidad · Refresco Iberia · Planta Alcolea</a:t>
+            </a:r>
+            <a:endParaRPr lang="en-US" sz="1000" dirty="0"/>
+          </a:p>
+        </p:txBody>
+      </p:sp>
+      <p:sp>
+        <p:nvSpPr>
+          <p:cNvPr id="10" name="Text 6"/>
+          <p:cNvSpPr/>
+          <p:nvPr/>
+        </p:nvSpPr>
+        <p:spPr>
+          <a:xfrm>
+            <a:off x="9281160" y="6364224"/>
+            <a:ext cx="2651760" cy="384048"/>
+          </a:xfrm>
+          <a:prstGeom prst="rect">
+            <a:avLst/>
+          </a:prstGeom>
+          <a:noFill/>
+          <a:ln/>
+        </p:spPr>
+        <p:txBody>
+          <a:bodyPr wrap="square" lIns="0" tIns="0" rIns="0" bIns="0" rtlCol="0" anchor="ctr"/>
+          <a:lstStyle/>
+          <a:p>
+            <a:pPr algn="r" indent="0" marL="0">
+              <a:buNone/>
+            </a:pPr>
+            <a:r>
+              <a:rPr lang="en-US" sz="1800" b="1" dirty="0">
+                <a:solidFill>
+                  <a:srgbClr val="FFFFFF"/>
+                </a:solidFill>
+                <a:latin typeface="Calibri" pitchFamily="34" charset="0"/>
+                <a:ea typeface="Calibri" pitchFamily="34" charset="-122"/>
+                <a:cs typeface="Calibri" pitchFamily="34" charset="-120"/>
+              </a:rPr>
+              <a:t>Refresco</a:t>
+            </a:r>
+            <a:endParaRPr lang="en-US" sz="1800" dirty="0"/>
+          </a:p>
+        </p:txBody>
+      </p:sp>
+      <p:sp>
+        <p:nvSpPr>
+          <p:cNvPr id="11" name="Text 7"/>
+          <p:cNvSpPr/>
+          <p:nvPr/>
+        </p:nvSpPr>
+        <p:spPr>
+          <a:xfrm>
+            <a:off x="54864" y="6492240"/>
+            <a:ext cx="201168" cy="201168"/>
+          </a:xfrm>
+          <a:prstGeom prst="rect">
+            <a:avLst/>
+          </a:prstGeom>
+          <a:noFill/>
+          <a:ln/>
+        </p:spPr>
+        <p:txBody>
+          <a:bodyPr wrap="square" lIns="0" tIns="0" rIns="0" bIns="0" rtlCol="0" anchor="ctr"/>
+          <a:lstStyle/>
+          <a:p>
+            <a:pPr algn="l" indent="0" marL="0">
+              <a:buNone/>
+            </a:pPr>
+            <a:r>
+              <a:rPr lang="en-US" sz="900" b="1" dirty="0">
+                <a:solidFill>
+                  <a:srgbClr val="FFFFFF"/>
+                </a:solidFill>
+                <a:latin typeface="Calibri" pitchFamily="34" charset="0"/>
+                <a:ea typeface="Calibri" pitchFamily="34" charset="-122"/>
+                <a:cs typeface="Calibri" pitchFamily="34" charset="-120"/>
+              </a:rPr>
+              <a:t>2</a:t>
+            </a:r>
+            <a:endParaRPr lang="en-US" sz="900" dirty="0"/>
+          </a:p>
+        </p:txBody>
       </p:sp>
     </p:spTree>
   </p:cSld>
@@ -1635,6 +1993,13 @@
 <file path=ppt/slides/slide3.xml><?xml version="1.0" encoding="utf-8"?>
 <p:sld xmlns:a="http://schemas.openxmlformats.org/drawingml/2006/main" xmlns:r="http://schemas.openxmlformats.org/officeDocument/2006/relationships" xmlns:p="http://schemas.openxmlformats.org/presentationml/2006/main">
   <p:cSld name="Slide 3">
+    <p:bg>
+      <p:bgPr>
+        <a:solidFill>
+          <a:srgbClr val="FAFCFA"/>
+        </a:solidFill>
+      </p:bgPr>
+    </p:bg>
     <p:spTree>
       <p:nvGrpSpPr>
         <p:cNvPr id="1" name=""/>
@@ -1651,14 +2016,41 @@
       </p:grpSpPr>
       <p:sp>
         <p:nvSpPr>
-          <p:cNvPr id="2" name="Text 0"/>
-          <p:cNvSpPr/>
-          <p:nvPr/>
-        </p:nvSpPr>
-        <p:spPr>
-          <a:xfrm>
-            <a:off x="2286000" y="320040"/>
-            <a:ext cx="7589520" cy="457200"/>
+          <p:cNvPr id="2" name="Shape 0"/>
+          <p:cNvSpPr/>
+          <p:nvPr/>
+        </p:nvSpPr>
+        <p:spPr>
+          <a:xfrm>
+            <a:off x="11292840" y="502920"/>
+            <a:ext cx="1417320" cy="1417320"/>
+          </a:xfrm>
+          <a:prstGeom prst="ellipse">
+            <a:avLst/>
+          </a:prstGeom>
+          <a:solidFill>
+            <a:srgbClr val="D8F3E3"/>
+          </a:solidFill>
+          <a:ln w="12700">
+            <a:solidFill>
+              <a:srgbClr val="FFFFFF">
+                <a:alpha val="0"/>
+              </a:srgbClr>
+            </a:solidFill>
+            <a:prstDash val="solid"/>
+          </a:ln>
+        </p:spPr>
+      </p:sp>
+      <p:sp>
+        <p:nvSpPr>
+          <p:cNvPr id="3" name="Text 1"/>
+          <p:cNvSpPr/>
+          <p:nvPr/>
+        </p:nvSpPr>
+        <p:spPr>
+          <a:xfrm>
+            <a:off x="384048" y="164592"/>
+            <a:ext cx="6858000" cy="384048"/>
           </a:xfrm>
           <a:prstGeom prst="rect">
             <a:avLst/>
@@ -1667,61 +2059,37 @@
           <a:ln/>
         </p:spPr>
         <p:txBody>
-          <a:bodyPr wrap="square" rtlCol="0" anchor="ctr"/>
-          <a:lstStyle/>
-          <a:p>
-            <a:pPr algn="ctr" indent="0" marL="0">
+          <a:bodyPr wrap="square" lIns="0" tIns="0" rIns="0" bIns="0" rtlCol="0" anchor="ctr"/>
+          <a:lstStyle/>
+          <a:p>
+            <a:pPr indent="0" marL="0">
               <a:buNone/>
             </a:pPr>
             <a:r>
-              <a:rPr lang="en-US" sz="1800" b="1" dirty="0">
+              <a:rPr lang="en-US" sz="2200" b="1" dirty="0">
                 <a:solidFill>
-                  <a:srgbClr val="000000"/>
+                  <a:srgbClr val="D9871A"/>
                 </a:solidFill>
                 <a:latin typeface="Calibri" pitchFamily="34" charset="0"/>
                 <a:ea typeface="Calibri" pitchFamily="34" charset="-122"/>
                 <a:cs typeface="Calibri" pitchFamily="34" charset="-120"/>
               </a:rPr>
-              <a:t>INSPECCIÓN SEPTIEMBRE 2026</a:t>
-            </a:r>
-            <a:endParaRPr lang="en-US" sz="1800" dirty="0"/>
-          </a:p>
-        </p:txBody>
-      </p:sp>
-      <p:pic>
-        <p:nvPicPr>
-          <p:cNvPr id="3" name="Image 0" descr="/workspace/inspecciones-calidad/samples/_tmp_EX-CALLE-FC43.png">    </p:cNvPr>
-          <p:cNvPicPr>
-            <a:picLocks noChangeAspect="1"/>
-          </p:cNvPicPr>
-          <p:nvPr/>
-        </p:nvPicPr>
-        <p:blipFill>
-          <a:blip r:embed="rId1"/>
-          <a:stretch>
-            <a:fillRect/>
-          </a:stretch>
-        </p:blipFill>
-        <p:spPr>
-          <a:xfrm>
-            <a:off x="640080" y="1051560"/>
-            <a:ext cx="5029200" cy="3657600"/>
-          </a:xfrm>
-          <a:prstGeom prst="rect">
-            <a:avLst/>
-          </a:prstGeom>
-        </p:spPr>
-      </p:pic>
-      <p:sp>
-        <p:nvSpPr>
-          <p:cNvPr id="4" name="Text 1"/>
-          <p:cNvSpPr/>
-          <p:nvPr/>
-        </p:nvSpPr>
-        <p:spPr>
-          <a:xfrm>
-            <a:off x="640080" y="2651760"/>
-            <a:ext cx="5029200" cy="457200"/>
+              <a:t>EXTERIORES</a:t>
+            </a:r>
+            <a:endParaRPr lang="en-US" sz="2200" dirty="0"/>
+          </a:p>
+        </p:txBody>
+      </p:sp>
+      <p:sp>
+        <p:nvSpPr>
+          <p:cNvPr id="4" name="Text 2"/>
+          <p:cNvSpPr/>
+          <p:nvPr/>
+        </p:nvSpPr>
+        <p:spPr>
+          <a:xfrm>
+            <a:off x="384048" y="530352"/>
+            <a:ext cx="5029200" cy="256032"/>
           </a:xfrm>
           <a:prstGeom prst="rect">
             <a:avLst/>
@@ -1730,69 +2098,328 @@
           <a:ln/>
         </p:spPr>
         <p:txBody>
-          <a:bodyPr wrap="square" rtlCol="0" anchor="ctr"/>
-          <a:lstStyle/>
-          <a:p>
-            <a:pPr algn="ctr" indent="0" marL="0">
+          <a:bodyPr wrap="square" lIns="0" tIns="0" rIns="0" bIns="0" rtlCol="0" anchor="ctr"/>
+          <a:lstStyle/>
+          <a:p>
+            <a:pPr indent="0" marL="0">
               <a:buNone/>
             </a:pPr>
             <a:r>
-              <a:rPr lang="en-US" sz="2800" b="1" dirty="0">
+              <a:rPr lang="en-US" sz="1200" b="1" dirty="0">
                 <a:solidFill>
-                  <a:srgbClr val="FFFFFF"/>
-                </a:solidFill>
-                <a:latin typeface="Arial" pitchFamily="34" charset="0"/>
-                <a:ea typeface="Arial" pitchFamily="34" charset="-122"/>
-                <a:cs typeface="Arial" pitchFamily="34" charset="-120"/>
-              </a:rPr>
-              <a:t>EJEMPLO</a:t>
-            </a:r>
-            <a:endParaRPr lang="en-US" sz="2800" dirty="0"/>
-          </a:p>
-        </p:txBody>
-      </p:sp>
-      <p:sp>
-        <p:nvSpPr>
-          <p:cNvPr id="5" name="Text 2"/>
-          <p:cNvSpPr/>
-          <p:nvPr/>
-        </p:nvSpPr>
-        <p:spPr>
-          <a:xfrm>
-            <a:off x="640080" y="4846320"/>
-            <a:ext cx="5029200" cy="640080"/>
-          </a:xfrm>
-          <a:prstGeom prst="rect">
-            <a:avLst/>
-          </a:prstGeom>
-          <a:noFill/>
-          <a:ln/>
-        </p:spPr>
-        <p:txBody>
-          <a:bodyPr wrap="square" rtlCol="0" anchor="ctr"/>
-          <a:lstStyle/>
-          <a:p>
-            <a:pPr algn="ctr" indent="0" marL="0">
-              <a:buNone/>
-            </a:pPr>
-            <a:r>
-              <a:rPr lang="en-US" sz="1100" dirty="0">
-                <a:solidFill>
-                  <a:srgbClr val="000000"/>
+                  <a:srgbClr val="03A64B"/>
                 </a:solidFill>
                 <a:latin typeface="Calibri" pitchFamily="34" charset="0"/>
                 <a:ea typeface="Calibri" pitchFamily="34" charset="-122"/>
                 <a:cs typeface="Calibri" pitchFamily="34" charset="-120"/>
               </a:rPr>
-              <a:t>EJEMPLO — REPARAR ESTANTERIA — CALLE FC-43</a:t>
-            </a:r>
-            <a:endParaRPr lang="en-US" sz="1100" dirty="0"/>
-          </a:p>
-        </p:txBody>
+              <a:t>FICHA 1 DE 1</a:t>
+            </a:r>
+            <a:endParaRPr lang="en-US" sz="1200" dirty="0"/>
+          </a:p>
+        </p:txBody>
+      </p:sp>
+      <p:sp>
+        <p:nvSpPr>
+          <p:cNvPr id="5" name="Shape 3"/>
+          <p:cNvSpPr/>
+          <p:nvPr/>
+        </p:nvSpPr>
+        <p:spPr>
+          <a:xfrm>
+            <a:off x="9281160" y="237744"/>
+            <a:ext cx="2514600" cy="329184"/>
+          </a:xfrm>
+          <a:prstGeom prst="roundRect">
+            <a:avLst>
+              <a:gd name="adj" fmla="val 44444"/>
+            </a:avLst>
+          </a:prstGeom>
+          <a:solidFill>
+            <a:srgbClr val="D9871A"/>
+          </a:solidFill>
+          <a:ln w="12700">
+            <a:solidFill>
+              <a:srgbClr val="FFFFFF">
+                <a:alpha val="0"/>
+              </a:srgbClr>
+            </a:solidFill>
+            <a:prstDash val="solid"/>
+          </a:ln>
+        </p:spPr>
+      </p:sp>
+      <p:sp>
+        <p:nvSpPr>
+          <p:cNvPr id="6" name="Text 4"/>
+          <p:cNvSpPr/>
+          <p:nvPr/>
+        </p:nvSpPr>
+        <p:spPr>
+          <a:xfrm>
+            <a:off x="9281160" y="237744"/>
+            <a:ext cx="2514600" cy="329184"/>
+          </a:xfrm>
+          <a:prstGeom prst="rect">
+            <a:avLst/>
+          </a:prstGeom>
+          <a:noFill/>
+          <a:ln/>
+        </p:spPr>
+        <p:txBody>
+          <a:bodyPr wrap="square" lIns="0" tIns="0" rIns="0" bIns="0" rtlCol="0" anchor="ctr"/>
+          <a:lstStyle/>
+          <a:p>
+            <a:pPr algn="ctr" indent="0" marL="0">
+              <a:buNone/>
+            </a:pPr>
+            <a:r>
+              <a:rPr lang="en-US" sz="900" b="1" dirty="0">
+                <a:solidFill>
+                  <a:srgbClr val="FFFFFF"/>
+                </a:solidFill>
+                <a:latin typeface="Calibri" pitchFamily="34" charset="0"/>
+                <a:ea typeface="Calibri" pitchFamily="34" charset="-122"/>
+                <a:cs typeface="Calibri" pitchFamily="34" charset="-120"/>
+              </a:rPr>
+              <a:t>INCIDENCIAS EXTERIORES</a:t>
+            </a:r>
+            <a:endParaRPr lang="en-US" sz="900" dirty="0"/>
+          </a:p>
+        </p:txBody>
+      </p:sp>
+      <p:sp>
+        <p:nvSpPr>
+          <p:cNvPr id="7" name="Shape 5"/>
+          <p:cNvSpPr/>
+          <p:nvPr/>
+        </p:nvSpPr>
+        <p:spPr>
+          <a:xfrm>
+            <a:off x="347472" y="896112"/>
+            <a:ext cx="5618988" cy="4526280"/>
+          </a:xfrm>
+          <a:prstGeom prst="roundRect">
+            <a:avLst>
+              <a:gd name="adj" fmla="val 2424"/>
+            </a:avLst>
+          </a:prstGeom>
+          <a:solidFill>
+            <a:srgbClr val="FFFFFF"/>
+          </a:solidFill>
+          <a:ln w="9525">
+            <a:solidFill>
+              <a:srgbClr val="E4EEE7"/>
+            </a:solidFill>
+            <a:prstDash val="solid"/>
+          </a:ln>
+          <a:effectLst>
+            <a:outerShdw sx="100000" sy="100000" kx="0" ky="0" algn="bl" rotWithShape="0" blurRad="101600" dist="25400" dir="16200000">
+              <a:srgbClr val="2F3E46">
+                <a:alpha val="10000"/>
+              </a:srgbClr>
+            </a:outerShdw>
+          </a:effectLst>
+        </p:spPr>
+      </p:sp>
+      <p:sp>
+        <p:nvSpPr>
+          <p:cNvPr id="8" name="Shape 6"/>
+          <p:cNvSpPr/>
+          <p:nvPr/>
+        </p:nvSpPr>
+        <p:spPr>
+          <a:xfrm>
+            <a:off x="347472" y="896112"/>
+            <a:ext cx="5618988" cy="3657600"/>
+          </a:xfrm>
+          <a:prstGeom prst="rect">
+            <a:avLst/>
+          </a:prstGeom>
+          <a:solidFill>
+            <a:srgbClr val="D5E6DB"/>
+          </a:solidFill>
+          <a:ln w="12700">
+            <a:solidFill>
+              <a:srgbClr val="FFFFFF">
+                <a:alpha val="0"/>
+              </a:srgbClr>
+            </a:solidFill>
+            <a:prstDash val="solid"/>
+          </a:ln>
+        </p:spPr>
       </p:sp>
       <p:pic>
         <p:nvPicPr>
-          <p:cNvPr id="6" name="Image 1" descr="/workspace/inspecciones-calidad/app/public/assets/sello-resuelto.png">    </p:cNvPr>
+          <p:cNvPr id="9" name="Image 0" descr="preencoded.png">    </p:cNvPr>
+          <p:cNvPicPr>
+            <a:picLocks noChangeAspect="1"/>
+          </p:cNvPicPr>
+          <p:nvPr/>
+        </p:nvPicPr>
+        <p:blipFill>
+          <a:blip r:embed="rId1"/>
+          <a:srcRect l="0" r="0" t="0" b="0"/>
+          <a:stretch/>
+        </p:blipFill>
+        <p:spPr>
+          <a:xfrm>
+            <a:off x="718566" y="896112"/>
+            <a:ext cx="4876800" cy="3657600"/>
+          </a:xfrm>
+          <a:prstGeom prst="rect">
+            <a:avLst/>
+          </a:prstGeom>
+        </p:spPr>
+      </p:pic>
+      <p:sp>
+        <p:nvSpPr>
+          <p:cNvPr id="10" name="Shape 7"/>
+          <p:cNvSpPr/>
+          <p:nvPr/>
+        </p:nvSpPr>
+        <p:spPr>
+          <a:xfrm>
+            <a:off x="4759452" y="987552"/>
+            <a:ext cx="1115568" cy="256032"/>
+          </a:xfrm>
+          <a:prstGeom prst="roundRect">
+            <a:avLst>
+              <a:gd name="adj" fmla="val 42857"/>
+            </a:avLst>
+          </a:prstGeom>
+          <a:solidFill>
+            <a:srgbClr val="ED7D31"/>
+          </a:solidFill>
+          <a:ln w="12700">
+            <a:solidFill>
+              <a:srgbClr val="FFFFFF">
+                <a:alpha val="0"/>
+              </a:srgbClr>
+            </a:solidFill>
+            <a:prstDash val="solid"/>
+          </a:ln>
+        </p:spPr>
+      </p:sp>
+      <p:sp>
+        <p:nvSpPr>
+          <p:cNvPr id="11" name="Text 8"/>
+          <p:cNvSpPr/>
+          <p:nvPr/>
+        </p:nvSpPr>
+        <p:spPr>
+          <a:xfrm>
+            <a:off x="4759452" y="987552"/>
+            <a:ext cx="1115568" cy="256032"/>
+          </a:xfrm>
+          <a:prstGeom prst="rect">
+            <a:avLst/>
+          </a:prstGeom>
+          <a:noFill/>
+          <a:ln/>
+        </p:spPr>
+        <p:txBody>
+          <a:bodyPr wrap="square" lIns="0" tIns="0" rIns="0" bIns="0" rtlCol="0" anchor="ctr"/>
+          <a:lstStyle/>
+          <a:p>
+            <a:pPr algn="ctr" indent="0" marL="0">
+              <a:buNone/>
+            </a:pPr>
+            <a:r>
+              <a:rPr lang="en-US" sz="800" b="1" dirty="0">
+                <a:solidFill>
+                  <a:srgbClr val="FFFFFF"/>
+                </a:solidFill>
+                <a:latin typeface="Calibri" pitchFamily="34" charset="0"/>
+                <a:ea typeface="Calibri" pitchFamily="34" charset="-122"/>
+                <a:cs typeface="Calibri" pitchFamily="34" charset="-120"/>
+              </a:rPr>
+              <a:t>PENDIENTE</a:t>
+            </a:r>
+            <a:endParaRPr lang="en-US" sz="800" dirty="0"/>
+          </a:p>
+        </p:txBody>
+      </p:sp>
+      <p:sp>
+        <p:nvSpPr>
+          <p:cNvPr id="12" name="Text 9"/>
+          <p:cNvSpPr/>
+          <p:nvPr/>
+        </p:nvSpPr>
+        <p:spPr>
+          <a:xfrm>
+            <a:off x="475488" y="4645152"/>
+            <a:ext cx="5362956" cy="201168"/>
+          </a:xfrm>
+          <a:prstGeom prst="rect">
+            <a:avLst/>
+          </a:prstGeom>
+          <a:noFill/>
+          <a:ln/>
+        </p:spPr>
+        <p:txBody>
+          <a:bodyPr wrap="square" lIns="0" tIns="0" rIns="0" bIns="0" rtlCol="0" anchor="ctr"/>
+          <a:lstStyle/>
+          <a:p>
+            <a:pPr indent="0" marL="0">
+              <a:buNone/>
+            </a:pPr>
+            <a:r>
+              <a:rPr lang="en-US" sz="1000" b="1" dirty="0">
+                <a:solidFill>
+                  <a:srgbClr val="D9871A"/>
+                </a:solidFill>
+                <a:latin typeface="Calibri" pitchFamily="34" charset="0"/>
+                <a:ea typeface="Calibri" pitchFamily="34" charset="-122"/>
+                <a:cs typeface="Calibri" pitchFamily="34" charset="-120"/>
+              </a:rPr>
+              <a:t>EX · ZONA A</a:t>
+            </a:r>
+            <a:endParaRPr lang="en-US" sz="1000" dirty="0"/>
+          </a:p>
+        </p:txBody>
+      </p:sp>
+      <p:sp>
+        <p:nvSpPr>
+          <p:cNvPr id="13" name="Text 10"/>
+          <p:cNvSpPr/>
+          <p:nvPr/>
+        </p:nvSpPr>
+        <p:spPr>
+          <a:xfrm>
+            <a:off x="475488" y="4846320"/>
+            <a:ext cx="5362956" cy="384048"/>
+          </a:xfrm>
+          <a:prstGeom prst="rect">
+            <a:avLst/>
+          </a:prstGeom>
+          <a:noFill/>
+          <a:ln/>
+        </p:spPr>
+        <p:txBody>
+          <a:bodyPr wrap="square" lIns="0" tIns="0" rIns="0" bIns="0" rtlCol="0" anchor="t"/>
+          <a:lstStyle/>
+          <a:p>
+            <a:pPr indent="0" marL="0">
+              <a:buNone/>
+            </a:pPr>
+            <a:r>
+              <a:rPr lang="en-US" sz="1100" b="1" dirty="0">
+                <a:solidFill>
+                  <a:srgbClr val="2F3E46"/>
+                </a:solidFill>
+                <a:latin typeface="Calibri" pitchFamily="34" charset="0"/>
+                <a:ea typeface="Calibri" pitchFamily="34" charset="-122"/>
+                <a:cs typeface="Calibri" pitchFamily="34" charset="-120"/>
+              </a:rPr>
+              <a:t>EJEMPLO — LIMPIEZA PENDIENTE — ZONA A</a:t>
+            </a:r>
+            <a:endParaRPr lang="en-US" sz="1100" dirty="0"/>
+          </a:p>
+        </p:txBody>
+      </p:sp>
+      <p:pic>
+        <p:nvPicPr>
+          <p:cNvPr id="14" name="Image 1" descr="preencoded.png">    </p:cNvPr>
           <p:cNvPicPr>
             <a:picLocks noChangeAspect="1"/>
           </p:cNvPicPr>
@@ -1806,8 +2433,8 @@
         </p:blipFill>
         <p:spPr>
           <a:xfrm>
-            <a:off x="4617720" y="2377440"/>
-            <a:ext cx="960120" cy="914400"/>
+            <a:off x="0" y="5333695"/>
+            <a:ext cx="12191695" cy="1524305"/>
           </a:xfrm>
           <a:prstGeom prst="rect">
             <a:avLst/>
@@ -1816,7 +2443,7 @@
       </p:pic>
       <p:pic>
         <p:nvPicPr>
-          <p:cNvPr id="7" name="Image 2" descr="/workspace/inspecciones-calidad/samples/_tmp_EX-CALLE-FC35.png">    </p:cNvPr>
+          <p:cNvPr id="15" name="Image 2" descr="preencoded.png">    </p:cNvPr>
           <p:cNvPicPr>
             <a:picLocks noChangeAspect="1"/>
           </p:cNvPicPr>
@@ -1830,8 +2457,8 @@
         </p:blipFill>
         <p:spPr>
           <a:xfrm>
-            <a:off x="6492240" y="1051560"/>
-            <a:ext cx="5029200" cy="3657600"/>
+            <a:off x="256032" y="5596128"/>
+            <a:ext cx="1024128" cy="1207008"/>
           </a:xfrm>
           <a:prstGeom prst="rect">
             <a:avLst/>
@@ -1840,14 +2467,14 @@
       </p:pic>
       <p:sp>
         <p:nvSpPr>
-          <p:cNvPr id="8" name="Text 3"/>
-          <p:cNvSpPr/>
-          <p:nvPr/>
-        </p:nvSpPr>
-        <p:spPr>
-          <a:xfrm>
-            <a:off x="6492240" y="2651760"/>
-            <a:ext cx="5029200" cy="457200"/>
+          <p:cNvPr id="16" name="Text 11"/>
+          <p:cNvSpPr/>
+          <p:nvPr/>
+        </p:nvSpPr>
+        <p:spPr>
+          <a:xfrm>
+            <a:off x="1389888" y="6473952"/>
+            <a:ext cx="7589520" cy="256032"/>
           </a:xfrm>
           <a:prstGeom prst="rect">
             <a:avLst/>
@@ -1856,96 +2483,37 @@
           <a:ln/>
         </p:spPr>
         <p:txBody>
-          <a:bodyPr wrap="square" rtlCol="0" anchor="ctr"/>
-          <a:lstStyle/>
-          <a:p>
-            <a:pPr algn="ctr" indent="0" marL="0">
+          <a:bodyPr wrap="square" lIns="0" tIns="0" rIns="0" bIns="0" rtlCol="0" anchor="ctr"/>
+          <a:lstStyle/>
+          <a:p>
+            <a:pPr indent="0" marL="0">
               <a:buNone/>
             </a:pPr>
             <a:r>
-              <a:rPr lang="en-US" sz="2800" b="1" dirty="0">
+              <a:rPr lang="en-US" sz="1000" b="1" dirty="0">
                 <a:solidFill>
                   <a:srgbClr val="FFFFFF"/>
-                </a:solidFill>
-                <a:latin typeface="Arial" pitchFamily="34" charset="0"/>
-                <a:ea typeface="Arial" pitchFamily="34" charset="-122"/>
-                <a:cs typeface="Arial" pitchFamily="34" charset="-120"/>
-              </a:rPr>
-              <a:t>EJEMPLO</a:t>
-            </a:r>
-            <a:endParaRPr lang="en-US" sz="2800" dirty="0"/>
-          </a:p>
-        </p:txBody>
-      </p:sp>
-      <p:sp>
-        <p:nvSpPr>
-          <p:cNvPr id="9" name="Text 4"/>
-          <p:cNvSpPr/>
-          <p:nvPr/>
-        </p:nvSpPr>
-        <p:spPr>
-          <a:xfrm>
-            <a:off x="6492240" y="4846320"/>
-            <a:ext cx="5029200" cy="640080"/>
-          </a:xfrm>
-          <a:prstGeom prst="rect">
-            <a:avLst/>
-          </a:prstGeom>
-          <a:noFill/>
-          <a:ln/>
-        </p:spPr>
-        <p:txBody>
-          <a:bodyPr wrap="square" rtlCol="0" anchor="ctr"/>
-          <a:lstStyle/>
-          <a:p>
-            <a:pPr algn="ctr" indent="0" marL="0">
-              <a:buNone/>
-            </a:pPr>
-            <a:r>
-              <a:rPr lang="en-US" sz="1100" dirty="0">
-                <a:solidFill>
-                  <a:srgbClr val="000000"/>
                 </a:solidFill>
                 <a:latin typeface="Calibri" pitchFamily="34" charset="0"/>
                 <a:ea typeface="Calibri" pitchFamily="34" charset="-122"/>
                 <a:cs typeface="Calibri" pitchFamily="34" charset="-120"/>
               </a:rPr>
-              <a:t>EJEMPLO — REPARAR ESTANTERIA — CALLE FC-35</a:t>
-            </a:r>
-            <a:endParaRPr lang="en-US" sz="1100" dirty="0"/>
-          </a:p>
-        </p:txBody>
-      </p:sp>
-      <p:sp>
-        <p:nvSpPr>
-          <p:cNvPr id="10" name="Shape 5"/>
-          <p:cNvSpPr/>
-          <p:nvPr/>
-        </p:nvSpPr>
-        <p:spPr>
-          <a:xfrm>
-            <a:off x="6629400" y="1188720"/>
-            <a:ext cx="1463040" cy="347472"/>
-          </a:xfrm>
-          <a:prstGeom prst="roundRect">
-            <a:avLst/>
-          </a:prstGeom>
-          <a:solidFill>
-            <a:srgbClr val="ED7D31"/>
-          </a:solidFill>
-          <a:ln/>
-        </p:spPr>
-      </p:sp>
-      <p:sp>
-        <p:nvSpPr>
-          <p:cNvPr id="11" name="Text 6"/>
-          <p:cNvSpPr/>
-          <p:nvPr/>
-        </p:nvSpPr>
-        <p:spPr>
-          <a:xfrm>
-            <a:off x="6629400" y="1188720"/>
-            <a:ext cx="1463040" cy="347472"/>
+              <a:t>Inspecciones calidad · Refresco Iberia · Planta Alcolea</a:t>
+            </a:r>
+            <a:endParaRPr lang="en-US" sz="1000" dirty="0"/>
+          </a:p>
+        </p:txBody>
+      </p:sp>
+      <p:sp>
+        <p:nvSpPr>
+          <p:cNvPr id="17" name="Text 12"/>
+          <p:cNvSpPr/>
+          <p:nvPr/>
+        </p:nvSpPr>
+        <p:spPr>
+          <a:xfrm>
+            <a:off x="9281160" y="6364224"/>
+            <a:ext cx="2651760" cy="384048"/>
           </a:xfrm>
           <a:prstGeom prst="rect">
             <a:avLst/>
@@ -1954,21 +2522,63 @@
           <a:ln/>
         </p:spPr>
         <p:txBody>
-          <a:bodyPr wrap="square" rtlCol="0" anchor="ctr"/>
-          <a:lstStyle/>
-          <a:p>
-            <a:pPr algn="ctr" indent="0" marL="0">
+          <a:bodyPr wrap="square" lIns="0" tIns="0" rIns="0" bIns="0" rtlCol="0" anchor="ctr"/>
+          <a:lstStyle/>
+          <a:p>
+            <a:pPr algn="r" indent="0" marL="0">
               <a:buNone/>
             </a:pPr>
             <a:r>
-              <a:rPr lang="en-US" sz="1100" b="1" dirty="0">
+              <a:rPr lang="en-US" sz="1800" b="1" dirty="0">
                 <a:solidFill>
                   <a:srgbClr val="FFFFFF"/>
                 </a:solidFill>
+                <a:latin typeface="Calibri" pitchFamily="34" charset="0"/>
+                <a:ea typeface="Calibri" pitchFamily="34" charset="-122"/>
+                <a:cs typeface="Calibri" pitchFamily="34" charset="-120"/>
               </a:rPr>
-              <a:t>PENDIENTE</a:t>
-            </a:r>
-            <a:endParaRPr lang="en-US" sz="1100" dirty="0"/>
+              <a:t>Refresco</a:t>
+            </a:r>
+            <a:endParaRPr lang="en-US" sz="1800" dirty="0"/>
+          </a:p>
+        </p:txBody>
+      </p:sp>
+      <p:sp>
+        <p:nvSpPr>
+          <p:cNvPr id="18" name="Text 13"/>
+          <p:cNvSpPr/>
+          <p:nvPr/>
+        </p:nvSpPr>
+        <p:spPr>
+          <a:xfrm>
+            <a:off x="54864" y="6492240"/>
+            <a:ext cx="201168" cy="201168"/>
+          </a:xfrm>
+          <a:prstGeom prst="rect">
+            <a:avLst/>
+          </a:prstGeom>
+          <a:noFill/>
+          <a:ln/>
+        </p:spPr>
+        <p:txBody>
+          <a:bodyPr wrap="square" lIns="0" tIns="0" rIns="0" bIns="0" rtlCol="0" anchor="ctr"/>
+          <a:lstStyle/>
+          <a:p>
+            <a:pPr algn="l" indent="0" marL="0">
+              <a:buNone/>
+            </a:pPr>
+            <a:r>
+              <a:rPr lang="en-US" sz="900" b="1" dirty="0">
+                <a:solidFill>
+                  <a:srgbClr val="FFFFFF"/>
+                </a:solidFill>
+                <a:latin typeface="Calibri" pitchFamily="34" charset="0"/>
+                <a:ea typeface="Calibri" pitchFamily="34" charset="-122"/>
+                <a:cs typeface="Calibri" pitchFamily="34" charset="-120"/>
+              </a:rPr>
+              <a:t>3</a:t>
+            </a:r>
+            <a:endParaRPr lang="en-US" sz="900" dirty="0"/>
           </a:p>
         </p:txBody>
       </p:sp>
@@ -1983,6 +2593,13 @@
 <file path=ppt/slides/slide4.xml><?xml version="1.0" encoding="utf-8"?>
 <p:sld xmlns:a="http://schemas.openxmlformats.org/drawingml/2006/main" xmlns:r="http://schemas.openxmlformats.org/officeDocument/2006/relationships" xmlns:p="http://schemas.openxmlformats.org/presentationml/2006/main">
   <p:cSld name="Slide 4">
+    <p:bg>
+      <p:bgPr>
+        <a:solidFill>
+          <a:srgbClr val="FAFCFA"/>
+        </a:solidFill>
+      </p:bgPr>
+    </p:bg>
     <p:spTree>
       <p:nvGrpSpPr>
         <p:cNvPr id="1" name=""/>
@@ -1999,14 +2616,68 @@
       </p:grpSpPr>
       <p:sp>
         <p:nvSpPr>
-          <p:cNvPr id="2" name="Text 0"/>
-          <p:cNvSpPr/>
-          <p:nvPr/>
-        </p:nvSpPr>
-        <p:spPr>
-          <a:xfrm>
-            <a:off x="457200" y="2560320"/>
-            <a:ext cx="11277295" cy="1097280"/>
+          <p:cNvPr id="2" name="Shape 0"/>
+          <p:cNvSpPr/>
+          <p:nvPr/>
+        </p:nvSpPr>
+        <p:spPr>
+          <a:xfrm>
+            <a:off x="-777240" y="1874520"/>
+            <a:ext cx="2148840" cy="2148840"/>
+          </a:xfrm>
+          <a:prstGeom prst="ellipse">
+            <a:avLst/>
+          </a:prstGeom>
+          <a:solidFill>
+            <a:srgbClr val="F0E4D0"/>
+          </a:solidFill>
+          <a:ln w="12700">
+            <a:solidFill>
+              <a:srgbClr val="FFFFFF">
+                <a:alpha val="0"/>
+              </a:srgbClr>
+            </a:solidFill>
+            <a:prstDash val="solid"/>
+          </a:ln>
+        </p:spPr>
+      </p:sp>
+      <p:sp>
+        <p:nvSpPr>
+          <p:cNvPr id="3" name="Shape 1"/>
+          <p:cNvSpPr/>
+          <p:nvPr/>
+        </p:nvSpPr>
+        <p:spPr>
+          <a:xfrm>
+            <a:off x="10561320" y="-320040"/>
+            <a:ext cx="2606040" cy="2606040"/>
+          </a:xfrm>
+          <a:prstGeom prst="ellipse">
+            <a:avLst/>
+          </a:prstGeom>
+          <a:solidFill>
+            <a:srgbClr val="D8F3E3"/>
+          </a:solidFill>
+          <a:ln w="12700">
+            <a:solidFill>
+              <a:srgbClr val="FFFFFF">
+                <a:alpha val="0"/>
+              </a:srgbClr>
+            </a:solidFill>
+            <a:prstDash val="solid"/>
+          </a:ln>
+        </p:spPr>
+      </p:sp>
+      <p:sp>
+        <p:nvSpPr>
+          <p:cNvPr id="4" name="Text 2"/>
+          <p:cNvSpPr/>
+          <p:nvPr/>
+        </p:nvSpPr>
+        <p:spPr>
+          <a:xfrm>
+            <a:off x="731520" y="2084832"/>
+            <a:ext cx="10725912" cy="292608"/>
           </a:xfrm>
           <a:prstGeom prst="rect">
             <a:avLst/>
@@ -2015,46 +2686,269 @@
           <a:ln/>
         </p:spPr>
         <p:txBody>
-          <a:bodyPr wrap="square" rtlCol="0" anchor="ctr"/>
+          <a:bodyPr wrap="square" lIns="0" tIns="0" rIns="0" bIns="0" rtlCol="0" anchor="ctr"/>
           <a:lstStyle/>
           <a:p>
             <a:pPr algn="ctr" indent="0" marL="0">
               <a:buNone/>
             </a:pPr>
             <a:r>
-              <a:rPr lang="en-US" sz="3600" b="1" dirty="0">
+              <a:rPr lang="en-US" sz="1200" b="1" spc="400" kern="0" dirty="0">
                 <a:solidFill>
-                  <a:srgbClr val="1F4E79"/>
+                  <a:srgbClr val="D9871A"/>
                 </a:solidFill>
                 <a:latin typeface="Calibri" pitchFamily="34" charset="0"/>
                 <a:ea typeface="Calibri" pitchFamily="34" charset="-122"/>
                 <a:cs typeface="Calibri" pitchFamily="34" charset="-120"/>
               </a:rPr>
-              <a:t>INCIDENCIAS LIMPIEZA</a:t>
-            </a:r>
-            <a:endParaRPr lang="en-US" sz="3600" dirty="0"/>
-          </a:p>
-        </p:txBody>
-      </p:sp>
-      <p:sp>
-        <p:nvSpPr>
-          <p:cNvPr id="3" name="Shape 1"/>
-          <p:cNvSpPr/>
-          <p:nvPr/>
-        </p:nvSpPr>
-        <p:spPr>
-          <a:xfrm>
-            <a:off x="4114800" y="3749040"/>
-            <a:ext cx="3931920" cy="73152"/>
-          </a:xfrm>
-          <a:prstGeom prst="rect">
-            <a:avLst/>
-          </a:prstGeom>
-          <a:solidFill>
-            <a:srgbClr val="FFC000"/>
-          </a:solidFill>
+              <a:t>DEPARTAMENTO</a:t>
+            </a:r>
+            <a:endParaRPr lang="en-US" sz="1200" dirty="0"/>
+          </a:p>
+        </p:txBody>
+      </p:sp>
+      <p:sp>
+        <p:nvSpPr>
+          <p:cNvPr id="5" name="Text 3"/>
+          <p:cNvSpPr/>
+          <p:nvPr/>
+        </p:nvSpPr>
+        <p:spPr>
+          <a:xfrm>
+            <a:off x="731520" y="2359152"/>
+            <a:ext cx="10725912" cy="777240"/>
+          </a:xfrm>
+          <a:prstGeom prst="rect">
+            <a:avLst/>
+          </a:prstGeom>
+          <a:noFill/>
           <a:ln/>
         </p:spPr>
+        <p:txBody>
+          <a:bodyPr wrap="square" lIns="0" tIns="0" rIns="0" bIns="0" rtlCol="0" anchor="ctr"/>
+          <a:lstStyle/>
+          <a:p>
+            <a:pPr algn="ctr" indent="0" marL="0">
+              <a:buNone/>
+            </a:pPr>
+            <a:r>
+              <a:rPr lang="en-US" sz="4400" b="1" dirty="0">
+                <a:solidFill>
+                  <a:srgbClr val="D9871A"/>
+                </a:solidFill>
+                <a:latin typeface="Calibri" pitchFamily="34" charset="0"/>
+                <a:ea typeface="Calibri" pitchFamily="34" charset="-122"/>
+                <a:cs typeface="Calibri" pitchFamily="34" charset="-120"/>
+              </a:rPr>
+              <a:t>JARABE</a:t>
+            </a:r>
+            <a:endParaRPr lang="en-US" sz="4400" dirty="0"/>
+          </a:p>
+        </p:txBody>
+      </p:sp>
+      <p:sp>
+        <p:nvSpPr>
+          <p:cNvPr id="6" name="Text 4"/>
+          <p:cNvSpPr/>
+          <p:nvPr/>
+        </p:nvSpPr>
+        <p:spPr>
+          <a:xfrm>
+            <a:off x="731520" y="3182112"/>
+            <a:ext cx="10725912" cy="640080"/>
+          </a:xfrm>
+          <a:prstGeom prst="rect">
+            <a:avLst/>
+          </a:prstGeom>
+          <a:noFill/>
+          <a:ln/>
+        </p:spPr>
+        <p:txBody>
+          <a:bodyPr wrap="square" lIns="0" tIns="0" rIns="0" bIns="0" rtlCol="0" anchor="ctr"/>
+          <a:lstStyle/>
+          <a:p>
+            <a:pPr algn="ctr" indent="0" marL="0">
+              <a:buNone/>
+            </a:pPr>
+            <a:r>
+              <a:rPr lang="en-US" sz="2400" b="1" dirty="0">
+                <a:solidFill>
+                  <a:srgbClr val="03A64B"/>
+                </a:solidFill>
+                <a:latin typeface="Calibri" pitchFamily="34" charset="0"/>
+                <a:ea typeface="Calibri" pitchFamily="34" charset="-122"/>
+                <a:cs typeface="Calibri" pitchFamily="34" charset="-120"/>
+              </a:rPr>
+              <a:t>INCIDENCIAS JARABE</a:t>
+            </a:r>
+            <a:endParaRPr lang="en-US" sz="2400" dirty="0"/>
+          </a:p>
+        </p:txBody>
+      </p:sp>
+      <p:pic>
+        <p:nvPicPr>
+          <p:cNvPr id="7" name="Image 0" descr="preencoded.png">    </p:cNvPr>
+          <p:cNvPicPr>
+            <a:picLocks noChangeAspect="1"/>
+          </p:cNvPicPr>
+          <p:nvPr/>
+        </p:nvPicPr>
+        <p:blipFill>
+          <a:blip r:embed="rId1"/>
+          <a:stretch>
+            <a:fillRect/>
+          </a:stretch>
+        </p:blipFill>
+        <p:spPr>
+          <a:xfrm>
+            <a:off x="0" y="5333695"/>
+            <a:ext cx="12191695" cy="1524305"/>
+          </a:xfrm>
+          <a:prstGeom prst="rect">
+            <a:avLst/>
+          </a:prstGeom>
+        </p:spPr>
+      </p:pic>
+      <p:pic>
+        <p:nvPicPr>
+          <p:cNvPr id="8" name="Image 1" descr="preencoded.png">    </p:cNvPr>
+          <p:cNvPicPr>
+            <a:picLocks noChangeAspect="1"/>
+          </p:cNvPicPr>
+          <p:nvPr/>
+        </p:nvPicPr>
+        <p:blipFill>
+          <a:blip r:embed="rId2"/>
+          <a:stretch>
+            <a:fillRect/>
+          </a:stretch>
+        </p:blipFill>
+        <p:spPr>
+          <a:xfrm>
+            <a:off x="256032" y="5596128"/>
+            <a:ext cx="1024128" cy="1207008"/>
+          </a:xfrm>
+          <a:prstGeom prst="rect">
+            <a:avLst/>
+          </a:prstGeom>
+        </p:spPr>
+      </p:pic>
+      <p:sp>
+        <p:nvSpPr>
+          <p:cNvPr id="9" name="Text 5"/>
+          <p:cNvSpPr/>
+          <p:nvPr/>
+        </p:nvSpPr>
+        <p:spPr>
+          <a:xfrm>
+            <a:off x="1389888" y="6473952"/>
+            <a:ext cx="7589520" cy="256032"/>
+          </a:xfrm>
+          <a:prstGeom prst="rect">
+            <a:avLst/>
+          </a:prstGeom>
+          <a:noFill/>
+          <a:ln/>
+        </p:spPr>
+        <p:txBody>
+          <a:bodyPr wrap="square" lIns="0" tIns="0" rIns="0" bIns="0" rtlCol="0" anchor="ctr"/>
+          <a:lstStyle/>
+          <a:p>
+            <a:pPr indent="0" marL="0">
+              <a:buNone/>
+            </a:pPr>
+            <a:r>
+              <a:rPr lang="en-US" sz="1000" b="1" dirty="0">
+                <a:solidFill>
+                  <a:srgbClr val="FFFFFF"/>
+                </a:solidFill>
+                <a:latin typeface="Calibri" pitchFamily="34" charset="0"/>
+                <a:ea typeface="Calibri" pitchFamily="34" charset="-122"/>
+                <a:cs typeface="Calibri" pitchFamily="34" charset="-120"/>
+              </a:rPr>
+              <a:t>Inspecciones calidad · Refresco Iberia · Planta Alcolea</a:t>
+            </a:r>
+            <a:endParaRPr lang="en-US" sz="1000" dirty="0"/>
+          </a:p>
+        </p:txBody>
+      </p:sp>
+      <p:sp>
+        <p:nvSpPr>
+          <p:cNvPr id="10" name="Text 6"/>
+          <p:cNvSpPr/>
+          <p:nvPr/>
+        </p:nvSpPr>
+        <p:spPr>
+          <a:xfrm>
+            <a:off x="9281160" y="6364224"/>
+            <a:ext cx="2651760" cy="384048"/>
+          </a:xfrm>
+          <a:prstGeom prst="rect">
+            <a:avLst/>
+          </a:prstGeom>
+          <a:noFill/>
+          <a:ln/>
+        </p:spPr>
+        <p:txBody>
+          <a:bodyPr wrap="square" lIns="0" tIns="0" rIns="0" bIns="0" rtlCol="0" anchor="ctr"/>
+          <a:lstStyle/>
+          <a:p>
+            <a:pPr algn="r" indent="0" marL="0">
+              <a:buNone/>
+            </a:pPr>
+            <a:r>
+              <a:rPr lang="en-US" sz="1800" b="1" dirty="0">
+                <a:solidFill>
+                  <a:srgbClr val="FFFFFF"/>
+                </a:solidFill>
+                <a:latin typeface="Calibri" pitchFamily="34" charset="0"/>
+                <a:ea typeface="Calibri" pitchFamily="34" charset="-122"/>
+                <a:cs typeface="Calibri" pitchFamily="34" charset="-120"/>
+              </a:rPr>
+              <a:t>Refresco</a:t>
+            </a:r>
+            <a:endParaRPr lang="en-US" sz="1800" dirty="0"/>
+          </a:p>
+        </p:txBody>
+      </p:sp>
+      <p:sp>
+        <p:nvSpPr>
+          <p:cNvPr id="11" name="Text 7"/>
+          <p:cNvSpPr/>
+          <p:nvPr/>
+        </p:nvSpPr>
+        <p:spPr>
+          <a:xfrm>
+            <a:off x="54864" y="6492240"/>
+            <a:ext cx="201168" cy="201168"/>
+          </a:xfrm>
+          <a:prstGeom prst="rect">
+            <a:avLst/>
+          </a:prstGeom>
+          <a:noFill/>
+          <a:ln/>
+        </p:spPr>
+        <p:txBody>
+          <a:bodyPr wrap="square" lIns="0" tIns="0" rIns="0" bIns="0" rtlCol="0" anchor="ctr"/>
+          <a:lstStyle/>
+          <a:p>
+            <a:pPr algn="l" indent="0" marL="0">
+              <a:buNone/>
+            </a:pPr>
+            <a:r>
+              <a:rPr lang="en-US" sz="900" b="1" dirty="0">
+                <a:solidFill>
+                  <a:srgbClr val="FFFFFF"/>
+                </a:solidFill>
+                <a:latin typeface="Calibri" pitchFamily="34" charset="0"/>
+                <a:ea typeface="Calibri" pitchFamily="34" charset="-122"/>
+                <a:cs typeface="Calibri" pitchFamily="34" charset="-120"/>
+              </a:rPr>
+              <a:t>4</a:t>
+            </a:r>
+            <a:endParaRPr lang="en-US" sz="900" dirty="0"/>
+          </a:p>
+        </p:txBody>
       </p:sp>
     </p:spTree>
   </p:cSld>
@@ -2067,6 +2961,13 @@
 <file path=ppt/slides/slide5.xml><?xml version="1.0" encoding="utf-8"?>
 <p:sld xmlns:a="http://schemas.openxmlformats.org/drawingml/2006/main" xmlns:r="http://schemas.openxmlformats.org/officeDocument/2006/relationships" xmlns:p="http://schemas.openxmlformats.org/presentationml/2006/main">
   <p:cSld name="Slide 5">
+    <p:bg>
+      <p:bgPr>
+        <a:solidFill>
+          <a:srgbClr val="FAFCFA"/>
+        </a:solidFill>
+      </p:bgPr>
+    </p:bg>
     <p:spTree>
       <p:nvGrpSpPr>
         <p:cNvPr id="1" name=""/>
@@ -2083,14 +2984,41 @@
       </p:grpSpPr>
       <p:sp>
         <p:nvSpPr>
-          <p:cNvPr id="2" name="Text 0"/>
-          <p:cNvSpPr/>
-          <p:nvPr/>
-        </p:nvSpPr>
-        <p:spPr>
-          <a:xfrm>
-            <a:off x="2286000" y="320040"/>
-            <a:ext cx="7589520" cy="457200"/>
+          <p:cNvPr id="2" name="Shape 0"/>
+          <p:cNvSpPr/>
+          <p:nvPr/>
+        </p:nvSpPr>
+        <p:spPr>
+          <a:xfrm>
+            <a:off x="11292840" y="502920"/>
+            <a:ext cx="1417320" cy="1417320"/>
+          </a:xfrm>
+          <a:prstGeom prst="ellipse">
+            <a:avLst/>
+          </a:prstGeom>
+          <a:solidFill>
+            <a:srgbClr val="D8F3E3"/>
+          </a:solidFill>
+          <a:ln w="12700">
+            <a:solidFill>
+              <a:srgbClr val="FFFFFF">
+                <a:alpha val="0"/>
+              </a:srgbClr>
+            </a:solidFill>
+            <a:prstDash val="solid"/>
+          </a:ln>
+        </p:spPr>
+      </p:sp>
+      <p:sp>
+        <p:nvSpPr>
+          <p:cNvPr id="3" name="Text 1"/>
+          <p:cNvSpPr/>
+          <p:nvPr/>
+        </p:nvSpPr>
+        <p:spPr>
+          <a:xfrm>
+            <a:off x="384048" y="164592"/>
+            <a:ext cx="6858000" cy="384048"/>
           </a:xfrm>
           <a:prstGeom prst="rect">
             <a:avLst/>
@@ -2099,61 +3027,37 @@
           <a:ln/>
         </p:spPr>
         <p:txBody>
-          <a:bodyPr wrap="square" rtlCol="0" anchor="ctr"/>
-          <a:lstStyle/>
-          <a:p>
-            <a:pPr algn="ctr" indent="0" marL="0">
+          <a:bodyPr wrap="square" lIns="0" tIns="0" rIns="0" bIns="0" rtlCol="0" anchor="ctr"/>
+          <a:lstStyle/>
+          <a:p>
+            <a:pPr indent="0" marL="0">
               <a:buNone/>
             </a:pPr>
             <a:r>
-              <a:rPr lang="en-US" sz="1800" b="1" dirty="0">
+              <a:rPr lang="en-US" sz="2200" b="1" dirty="0">
                 <a:solidFill>
-                  <a:srgbClr val="000000"/>
+                  <a:srgbClr val="D9871A"/>
                 </a:solidFill>
                 <a:latin typeface="Calibri" pitchFamily="34" charset="0"/>
                 <a:ea typeface="Calibri" pitchFamily="34" charset="-122"/>
                 <a:cs typeface="Calibri" pitchFamily="34" charset="-120"/>
               </a:rPr>
-              <a:t>INSPECCIÓN SEPTIEMBRE 2026</a:t>
-            </a:r>
-            <a:endParaRPr lang="en-US" sz="1800" dirty="0"/>
-          </a:p>
-        </p:txBody>
-      </p:sp>
-      <p:pic>
-        <p:nvPicPr>
-          <p:cNvPr id="3" name="Image 0" descr="/workspace/inspecciones-calidad/samples/_tmp_LI-ZONA-A.png">    </p:cNvPr>
-          <p:cNvPicPr>
-            <a:picLocks noChangeAspect="1"/>
-          </p:cNvPicPr>
-          <p:nvPr/>
-        </p:nvPicPr>
-        <p:blipFill>
-          <a:blip r:embed="rId1"/>
-          <a:stretch>
-            <a:fillRect/>
-          </a:stretch>
-        </p:blipFill>
-        <p:spPr>
-          <a:xfrm>
-            <a:off x="3794760" y="1051560"/>
-            <a:ext cx="4572000" cy="3657600"/>
-          </a:xfrm>
-          <a:prstGeom prst="rect">
-            <a:avLst/>
-          </a:prstGeom>
-        </p:spPr>
-      </p:pic>
-      <p:sp>
-        <p:nvSpPr>
-          <p:cNvPr id="4" name="Text 1"/>
-          <p:cNvSpPr/>
-          <p:nvPr/>
-        </p:nvSpPr>
-        <p:spPr>
-          <a:xfrm>
-            <a:off x="3794760" y="2651760"/>
-            <a:ext cx="4572000" cy="457200"/>
+              <a:t>JARABE</a:t>
+            </a:r>
+            <a:endParaRPr lang="en-US" sz="2200" dirty="0"/>
+          </a:p>
+        </p:txBody>
+      </p:sp>
+      <p:sp>
+        <p:nvSpPr>
+          <p:cNvPr id="4" name="Text 2"/>
+          <p:cNvSpPr/>
+          <p:nvPr/>
+        </p:nvSpPr>
+        <p:spPr>
+          <a:xfrm>
+            <a:off x="384048" y="530352"/>
+            <a:ext cx="5029200" cy="256032"/>
           </a:xfrm>
           <a:prstGeom prst="rect">
             <a:avLst/>
@@ -2162,96 +3066,66 @@
           <a:ln/>
         </p:spPr>
         <p:txBody>
-          <a:bodyPr wrap="square" rtlCol="0" anchor="ctr"/>
-          <a:lstStyle/>
-          <a:p>
-            <a:pPr algn="ctr" indent="0" marL="0">
+          <a:bodyPr wrap="square" lIns="0" tIns="0" rIns="0" bIns="0" rtlCol="0" anchor="ctr"/>
+          <a:lstStyle/>
+          <a:p>
+            <a:pPr indent="0" marL="0">
               <a:buNone/>
             </a:pPr>
             <a:r>
-              <a:rPr lang="en-US" sz="2800" b="1" dirty="0">
+              <a:rPr lang="en-US" sz="1200" b="1" dirty="0">
                 <a:solidFill>
-                  <a:srgbClr val="FFFFFF"/>
-                </a:solidFill>
-                <a:latin typeface="Arial" pitchFamily="34" charset="0"/>
-                <a:ea typeface="Arial" pitchFamily="34" charset="-122"/>
-                <a:cs typeface="Arial" pitchFamily="34" charset="-120"/>
-              </a:rPr>
-              <a:t>EJEMPLO</a:t>
-            </a:r>
-            <a:endParaRPr lang="en-US" sz="2800" dirty="0"/>
-          </a:p>
-        </p:txBody>
-      </p:sp>
-      <p:sp>
-        <p:nvSpPr>
-          <p:cNvPr id="5" name="Text 2"/>
-          <p:cNvSpPr/>
-          <p:nvPr/>
-        </p:nvSpPr>
-        <p:spPr>
-          <a:xfrm>
-            <a:off x="3794760" y="4846320"/>
-            <a:ext cx="4572000" cy="640080"/>
-          </a:xfrm>
-          <a:prstGeom prst="rect">
-            <a:avLst/>
-          </a:prstGeom>
-          <a:noFill/>
-          <a:ln/>
-        </p:spPr>
-        <p:txBody>
-          <a:bodyPr wrap="square" rtlCol="0" anchor="ctr"/>
-          <a:lstStyle/>
-          <a:p>
-            <a:pPr algn="ctr" indent="0" marL="0">
-              <a:buNone/>
-            </a:pPr>
-            <a:r>
-              <a:rPr lang="en-US" sz="1100" dirty="0">
-                <a:solidFill>
-                  <a:srgbClr val="000000"/>
+                  <a:srgbClr val="03A64B"/>
                 </a:solidFill>
                 <a:latin typeface="Calibri" pitchFamily="34" charset="0"/>
                 <a:ea typeface="Calibri" pitchFamily="34" charset="-122"/>
                 <a:cs typeface="Calibri" pitchFamily="34" charset="-120"/>
               </a:rPr>
-              <a:t>EJEMPLO — LIMPIEZA PENDIENTE — ZONA A</a:t>
-            </a:r>
-            <a:endParaRPr lang="en-US" sz="1100" dirty="0"/>
-          </a:p>
-        </p:txBody>
-      </p:sp>
-      <p:sp>
-        <p:nvSpPr>
-          <p:cNvPr id="6" name="Shape 3"/>
-          <p:cNvSpPr/>
-          <p:nvPr/>
-        </p:nvSpPr>
-        <p:spPr>
-          <a:xfrm>
-            <a:off x="3931920" y="1188720"/>
-            <a:ext cx="1463040" cy="347472"/>
+              <a:t>FICHA 1 DE 1</a:t>
+            </a:r>
+            <a:endParaRPr lang="en-US" sz="1200" dirty="0"/>
+          </a:p>
+        </p:txBody>
+      </p:sp>
+      <p:sp>
+        <p:nvSpPr>
+          <p:cNvPr id="5" name="Shape 3"/>
+          <p:cNvSpPr/>
+          <p:nvPr/>
+        </p:nvSpPr>
+        <p:spPr>
+          <a:xfrm>
+            <a:off x="9281160" y="237744"/>
+            <a:ext cx="2514600" cy="329184"/>
           </a:xfrm>
           <a:prstGeom prst="roundRect">
-            <a:avLst/>
-          </a:prstGeom>
-          <a:solidFill>
-            <a:srgbClr val="ED7D31"/>
-          </a:solidFill>
-          <a:ln/>
-        </p:spPr>
-      </p:sp>
-      <p:sp>
-        <p:nvSpPr>
-          <p:cNvPr id="7" name="Text 4"/>
-          <p:cNvSpPr/>
-          <p:nvPr/>
-        </p:nvSpPr>
-        <p:spPr>
-          <a:xfrm>
-            <a:off x="3931920" y="1188720"/>
-            <a:ext cx="1463040" cy="347472"/>
+            <a:avLst>
+              <a:gd name="adj" fmla="val 44444"/>
+            </a:avLst>
+          </a:prstGeom>
+          <a:solidFill>
+            <a:srgbClr val="D9871A"/>
+          </a:solidFill>
+          <a:ln w="12700">
+            <a:solidFill>
+              <a:srgbClr val="FFFFFF">
+                <a:alpha val="0"/>
+              </a:srgbClr>
+            </a:solidFill>
+            <a:prstDash val="solid"/>
+          </a:ln>
+        </p:spPr>
+      </p:sp>
+      <p:sp>
+        <p:nvSpPr>
+          <p:cNvPr id="6" name="Text 4"/>
+          <p:cNvSpPr/>
+          <p:nvPr/>
+        </p:nvSpPr>
+        <p:spPr>
+          <a:xfrm>
+            <a:off x="9281160" y="237744"/>
+            <a:ext cx="2514600" cy="329184"/>
           </a:xfrm>
           <a:prstGeom prst="rect">
             <a:avLst/>
@@ -2260,143 +3134,150 @@
           <a:ln/>
         </p:spPr>
         <p:txBody>
-          <a:bodyPr wrap="square" rtlCol="0" anchor="ctr"/>
+          <a:bodyPr wrap="square" lIns="0" tIns="0" rIns="0" bIns="0" rtlCol="0" anchor="ctr"/>
           <a:lstStyle/>
           <a:p>
             <a:pPr algn="ctr" indent="0" marL="0">
               <a:buNone/>
             </a:pPr>
             <a:r>
-              <a:rPr lang="en-US" sz="1100" b="1" dirty="0">
+              <a:rPr lang="en-US" sz="900" b="1" dirty="0">
                 <a:solidFill>
                   <a:srgbClr val="FFFFFF"/>
-                </a:solidFill>
-              </a:rPr>
-              <a:t>PENDIENTE</a:t>
-            </a:r>
-            <a:endParaRPr lang="en-US" sz="1100" dirty="0"/>
-          </a:p>
-        </p:txBody>
-      </p:sp>
-    </p:spTree>
-  </p:cSld>
-  <p:clrMapOvr>
-    <a:masterClrMapping/>
-  </p:clrMapOvr>
-</p:sld>
-</file>
-
-<file path=ppt/slides/slide6.xml><?xml version="1.0" encoding="utf-8"?>
-<p:sld xmlns:a="http://schemas.openxmlformats.org/drawingml/2006/main" xmlns:r="http://schemas.openxmlformats.org/officeDocument/2006/relationships" xmlns:p="http://schemas.openxmlformats.org/presentationml/2006/main">
-  <p:cSld name="Slide 6">
-    <p:spTree>
-      <p:nvGrpSpPr>
-        <p:cNvPr id="1" name=""/>
-        <p:cNvGrpSpPr/>
-        <p:nvPr/>
-      </p:nvGrpSpPr>
-      <p:grpSpPr>
-        <a:xfrm>
-          <a:off x="0" y="0"/>
-          <a:ext cx="0" cy="0"/>
-          <a:chOff x="0" y="0"/>
-          <a:chExt cx="0" cy="0"/>
-        </a:xfrm>
-      </p:grpSpPr>
-      <p:sp>
-        <p:nvSpPr>
-          <p:cNvPr id="2" name="Text 0"/>
-          <p:cNvSpPr/>
-          <p:nvPr/>
-        </p:nvSpPr>
-        <p:spPr>
-          <a:xfrm>
-            <a:off x="457200" y="2560320"/>
-            <a:ext cx="11277295" cy="1097280"/>
-          </a:xfrm>
-          <a:prstGeom prst="rect">
-            <a:avLst/>
-          </a:prstGeom>
-          <a:noFill/>
-          <a:ln/>
-        </p:spPr>
-        <p:txBody>
-          <a:bodyPr wrap="square" rtlCol="0" anchor="ctr"/>
-          <a:lstStyle/>
-          <a:p>
-            <a:pPr algn="ctr" indent="0" marL="0">
-              <a:buNone/>
-            </a:pPr>
-            <a:r>
-              <a:rPr lang="en-US" sz="3600" b="1" dirty="0">
-                <a:solidFill>
-                  <a:srgbClr val="1F4E79"/>
                 </a:solidFill>
                 <a:latin typeface="Calibri" pitchFamily="34" charset="0"/>
                 <a:ea typeface="Calibri" pitchFamily="34" charset="-122"/>
                 <a:cs typeface="Calibri" pitchFamily="34" charset="-120"/>
               </a:rPr>
-              <a:t>INCIDENCIAS VESTUARIOS</a:t>
-            </a:r>
-            <a:endParaRPr lang="en-US" sz="3600" dirty="0"/>
-          </a:p>
-        </p:txBody>
-      </p:sp>
-      <p:sp>
-        <p:nvSpPr>
-          <p:cNvPr id="3" name="Shape 1"/>
-          <p:cNvSpPr/>
-          <p:nvPr/>
-        </p:nvSpPr>
-        <p:spPr>
-          <a:xfrm>
-            <a:off x="4114800" y="3749040"/>
-            <a:ext cx="3931920" cy="73152"/>
-          </a:xfrm>
-          <a:prstGeom prst="rect">
-            <a:avLst/>
-          </a:prstGeom>
-          <a:solidFill>
-            <a:srgbClr val="FFC000"/>
-          </a:solidFill>
-          <a:ln/>
-        </p:spPr>
-      </p:sp>
-    </p:spTree>
-  </p:cSld>
-  <p:clrMapOvr>
-    <a:masterClrMapping/>
-  </p:clrMapOvr>
-</p:sld>
-</file>
-
-<file path=ppt/slides/slide7.xml><?xml version="1.0" encoding="utf-8"?>
-<p:sld xmlns:a="http://schemas.openxmlformats.org/drawingml/2006/main" xmlns:r="http://schemas.openxmlformats.org/officeDocument/2006/relationships" xmlns:p="http://schemas.openxmlformats.org/presentationml/2006/main">
-  <p:cSld name="Slide 7">
-    <p:spTree>
-      <p:nvGrpSpPr>
-        <p:cNvPr id="1" name=""/>
-        <p:cNvGrpSpPr/>
-        <p:nvPr/>
-      </p:nvGrpSpPr>
-      <p:grpSpPr>
-        <a:xfrm>
-          <a:off x="0" y="0"/>
-          <a:ext cx="0" cy="0"/>
-          <a:chOff x="0" y="0"/>
-          <a:chExt cx="0" cy="0"/>
-        </a:xfrm>
-      </p:grpSpPr>
-      <p:sp>
-        <p:nvSpPr>
-          <p:cNvPr id="2" name="Text 0"/>
-          <p:cNvSpPr/>
-          <p:nvPr/>
-        </p:nvSpPr>
-        <p:spPr>
-          <a:xfrm>
-            <a:off x="2286000" y="320040"/>
-            <a:ext cx="7589520" cy="457200"/>
+              <a:t>INCIDENCIAS JARABE</a:t>
+            </a:r>
+            <a:endParaRPr lang="en-US" sz="900" dirty="0"/>
+          </a:p>
+        </p:txBody>
+      </p:sp>
+      <p:sp>
+        <p:nvSpPr>
+          <p:cNvPr id="7" name="Shape 5"/>
+          <p:cNvSpPr/>
+          <p:nvPr/>
+        </p:nvSpPr>
+        <p:spPr>
+          <a:xfrm>
+            <a:off x="347472" y="896112"/>
+            <a:ext cx="5618988" cy="4526280"/>
+          </a:xfrm>
+          <a:prstGeom prst="roundRect">
+            <a:avLst>
+              <a:gd name="adj" fmla="val 2424"/>
+            </a:avLst>
+          </a:prstGeom>
+          <a:solidFill>
+            <a:srgbClr val="FFFFFF"/>
+          </a:solidFill>
+          <a:ln w="9525">
+            <a:solidFill>
+              <a:srgbClr val="E4EEE7"/>
+            </a:solidFill>
+            <a:prstDash val="solid"/>
+          </a:ln>
+          <a:effectLst>
+            <a:outerShdw sx="100000" sy="100000" kx="0" ky="0" algn="bl" rotWithShape="0" blurRad="101600" dist="25400" dir="16200000">
+              <a:srgbClr val="2F3E46">
+                <a:alpha val="10000"/>
+              </a:srgbClr>
+            </a:outerShdw>
+          </a:effectLst>
+        </p:spPr>
+      </p:sp>
+      <p:sp>
+        <p:nvSpPr>
+          <p:cNvPr id="8" name="Shape 6"/>
+          <p:cNvSpPr/>
+          <p:nvPr/>
+        </p:nvSpPr>
+        <p:spPr>
+          <a:xfrm>
+            <a:off x="347472" y="896112"/>
+            <a:ext cx="5618988" cy="3657600"/>
+          </a:xfrm>
+          <a:prstGeom prst="rect">
+            <a:avLst/>
+          </a:prstGeom>
+          <a:solidFill>
+            <a:srgbClr val="D5E6DB"/>
+          </a:solidFill>
+          <a:ln w="12700">
+            <a:solidFill>
+              <a:srgbClr val="FFFFFF">
+                <a:alpha val="0"/>
+              </a:srgbClr>
+            </a:solidFill>
+            <a:prstDash val="solid"/>
+          </a:ln>
+        </p:spPr>
+      </p:sp>
+      <p:pic>
+        <p:nvPicPr>
+          <p:cNvPr id="9" name="Image 0" descr="preencoded.png">    </p:cNvPr>
+          <p:cNvPicPr>
+            <a:picLocks noChangeAspect="1"/>
+          </p:cNvPicPr>
+          <p:nvPr/>
+        </p:nvPicPr>
+        <p:blipFill>
+          <a:blip r:embed="rId1"/>
+          <a:srcRect l="0" r="0" t="0" b="0"/>
+          <a:stretch/>
+        </p:blipFill>
+        <p:spPr>
+          <a:xfrm>
+            <a:off x="718566" y="896112"/>
+            <a:ext cx="4876800" cy="3657600"/>
+          </a:xfrm>
+          <a:prstGeom prst="rect">
+            <a:avLst/>
+          </a:prstGeom>
+        </p:spPr>
+      </p:pic>
+      <p:sp>
+        <p:nvSpPr>
+          <p:cNvPr id="10" name="Shape 7"/>
+          <p:cNvSpPr/>
+          <p:nvPr/>
+        </p:nvSpPr>
+        <p:spPr>
+          <a:xfrm>
+            <a:off x="4759452" y="987552"/>
+            <a:ext cx="1115568" cy="256032"/>
+          </a:xfrm>
+          <a:prstGeom prst="roundRect">
+            <a:avLst>
+              <a:gd name="adj" fmla="val 42857"/>
+            </a:avLst>
+          </a:prstGeom>
+          <a:solidFill>
+            <a:srgbClr val="ED7D31"/>
+          </a:solidFill>
+          <a:ln w="12700">
+            <a:solidFill>
+              <a:srgbClr val="FFFFFF">
+                <a:alpha val="0"/>
+              </a:srgbClr>
+            </a:solidFill>
+            <a:prstDash val="solid"/>
+          </a:ln>
+        </p:spPr>
+      </p:sp>
+      <p:sp>
+        <p:nvSpPr>
+          <p:cNvPr id="11" name="Text 8"/>
+          <p:cNvSpPr/>
+          <p:nvPr/>
+        </p:nvSpPr>
+        <p:spPr>
+          <a:xfrm>
+            <a:off x="4759452" y="987552"/>
+            <a:ext cx="1115568" cy="256032"/>
           </a:xfrm>
           <a:prstGeom prst="rect">
             <a:avLst/>
@@ -2405,61 +3286,37 @@
           <a:ln/>
         </p:spPr>
         <p:txBody>
-          <a:bodyPr wrap="square" rtlCol="0" anchor="ctr"/>
+          <a:bodyPr wrap="square" lIns="0" tIns="0" rIns="0" bIns="0" rtlCol="0" anchor="ctr"/>
           <a:lstStyle/>
           <a:p>
             <a:pPr algn="ctr" indent="0" marL="0">
               <a:buNone/>
             </a:pPr>
             <a:r>
-              <a:rPr lang="en-US" sz="1800" b="1" dirty="0">
+              <a:rPr lang="en-US" sz="800" b="1" dirty="0">
                 <a:solidFill>
-                  <a:srgbClr val="000000"/>
+                  <a:srgbClr val="FFFFFF"/>
                 </a:solidFill>
                 <a:latin typeface="Calibri" pitchFamily="34" charset="0"/>
                 <a:ea typeface="Calibri" pitchFamily="34" charset="-122"/>
                 <a:cs typeface="Calibri" pitchFamily="34" charset="-120"/>
               </a:rPr>
-              <a:t>INSPECCIÓN SEPTIEMBRE 2026</a:t>
-            </a:r>
-            <a:endParaRPr lang="en-US" sz="1800" dirty="0"/>
-          </a:p>
-        </p:txBody>
-      </p:sp>
-      <p:pic>
-        <p:nvPicPr>
-          <p:cNvPr id="3" name="Image 0" descr="/workspace/inspecciones-calidad/samples/_tmp_V-VEST-01.png">    </p:cNvPr>
-          <p:cNvPicPr>
-            <a:picLocks noChangeAspect="1"/>
-          </p:cNvPicPr>
-          <p:nvPr/>
-        </p:nvPicPr>
-        <p:blipFill>
-          <a:blip r:embed="rId1"/>
-          <a:stretch>
-            <a:fillRect/>
-          </a:stretch>
-        </p:blipFill>
-        <p:spPr>
-          <a:xfrm>
-            <a:off x="640080" y="1051560"/>
-            <a:ext cx="5029200" cy="3657600"/>
-          </a:xfrm>
-          <a:prstGeom prst="rect">
-            <a:avLst/>
-          </a:prstGeom>
-        </p:spPr>
-      </p:pic>
-      <p:sp>
-        <p:nvSpPr>
-          <p:cNvPr id="4" name="Text 1"/>
-          <p:cNvSpPr/>
-          <p:nvPr/>
-        </p:nvSpPr>
-        <p:spPr>
-          <a:xfrm>
-            <a:off x="640080" y="2651760"/>
-            <a:ext cx="5029200" cy="457200"/>
+              <a:t>PENDIENTE</a:t>
+            </a:r>
+            <a:endParaRPr lang="en-US" sz="800" dirty="0"/>
+          </a:p>
+        </p:txBody>
+      </p:sp>
+      <p:sp>
+        <p:nvSpPr>
+          <p:cNvPr id="12" name="Text 9"/>
+          <p:cNvSpPr/>
+          <p:nvPr/>
+        </p:nvSpPr>
+        <p:spPr>
+          <a:xfrm>
+            <a:off x="475488" y="4645152"/>
+            <a:ext cx="5362956" cy="201168"/>
           </a:xfrm>
           <a:prstGeom prst="rect">
             <a:avLst/>
@@ -2468,69 +3325,130 @@
           <a:ln/>
         </p:spPr>
         <p:txBody>
-          <a:bodyPr wrap="square" rtlCol="0" anchor="ctr"/>
-          <a:lstStyle/>
-          <a:p>
-            <a:pPr algn="ctr" indent="0" marL="0">
+          <a:bodyPr wrap="square" lIns="0" tIns="0" rIns="0" bIns="0" rtlCol="0" anchor="ctr"/>
+          <a:lstStyle/>
+          <a:p>
+            <a:pPr indent="0" marL="0">
               <a:buNone/>
             </a:pPr>
             <a:r>
-              <a:rPr lang="en-US" sz="2800" b="1" dirty="0">
+              <a:rPr lang="en-US" sz="1000" b="1" dirty="0">
                 <a:solidFill>
-                  <a:srgbClr val="FFFFFF"/>
-                </a:solidFill>
-                <a:latin typeface="Arial" pitchFamily="34" charset="0"/>
-                <a:ea typeface="Arial" pitchFamily="34" charset="-122"/>
-                <a:cs typeface="Arial" pitchFamily="34" charset="-120"/>
-              </a:rPr>
-              <a:t>EJEMPLO</a:t>
-            </a:r>
-            <a:endParaRPr lang="en-US" sz="2800" dirty="0"/>
-          </a:p>
-        </p:txBody>
-      </p:sp>
-      <p:sp>
-        <p:nvSpPr>
-          <p:cNvPr id="5" name="Text 2"/>
-          <p:cNvSpPr/>
-          <p:nvPr/>
-        </p:nvSpPr>
-        <p:spPr>
-          <a:xfrm>
-            <a:off x="640080" y="4846320"/>
-            <a:ext cx="5029200" cy="640080"/>
-          </a:xfrm>
-          <a:prstGeom prst="rect">
-            <a:avLst/>
-          </a:prstGeom>
-          <a:noFill/>
-          <a:ln/>
-        </p:spPr>
-        <p:txBody>
-          <a:bodyPr wrap="square" rtlCol="0" anchor="ctr"/>
-          <a:lstStyle/>
-          <a:p>
-            <a:pPr algn="ctr" indent="0" marL="0">
-              <a:buNone/>
-            </a:pPr>
-            <a:r>
-              <a:rPr lang="en-US" sz="1100" dirty="0">
-                <a:solidFill>
-                  <a:srgbClr val="000000"/>
+                  <a:srgbClr val="D9871A"/>
                 </a:solidFill>
                 <a:latin typeface="Calibri" pitchFamily="34" charset="0"/>
                 <a:ea typeface="Calibri" pitchFamily="34" charset="-122"/>
                 <a:cs typeface="Calibri" pitchFamily="34" charset="-120"/>
               </a:rPr>
-              <a:t>EJEMPLO — TAQUILLA DAÑADA — VESTUARIO 01</a:t>
+              <a:t>J- · CALLE FC-43</a:t>
+            </a:r>
+            <a:endParaRPr lang="en-US" sz="1000" dirty="0"/>
+          </a:p>
+        </p:txBody>
+      </p:sp>
+      <p:sp>
+        <p:nvSpPr>
+          <p:cNvPr id="13" name="Text 10"/>
+          <p:cNvSpPr/>
+          <p:nvPr/>
+        </p:nvSpPr>
+        <p:spPr>
+          <a:xfrm>
+            <a:off x="475488" y="4846320"/>
+            <a:ext cx="5362956" cy="384048"/>
+          </a:xfrm>
+          <a:prstGeom prst="rect">
+            <a:avLst/>
+          </a:prstGeom>
+          <a:noFill/>
+          <a:ln/>
+        </p:spPr>
+        <p:txBody>
+          <a:bodyPr wrap="square" lIns="0" tIns="0" rIns="0" bIns="0" rtlCol="0" anchor="t"/>
+          <a:lstStyle/>
+          <a:p>
+            <a:pPr indent="0" marL="0">
+              <a:buNone/>
+            </a:pPr>
+            <a:r>
+              <a:rPr lang="en-US" sz="1100" b="1" dirty="0">
+                <a:solidFill>
+                  <a:srgbClr val="2F3E46"/>
+                </a:solidFill>
+                <a:latin typeface="Calibri" pitchFamily="34" charset="0"/>
+                <a:ea typeface="Calibri" pitchFamily="34" charset="-122"/>
+                <a:cs typeface="Calibri" pitchFamily="34" charset="-120"/>
+              </a:rPr>
+              <a:t>REPARAR ESTANTERIA JUNTO CALLE FC-43</a:t>
             </a:r>
             <a:endParaRPr lang="en-US" sz="1100" dirty="0"/>
           </a:p>
         </p:txBody>
+      </p:sp>
+      <p:sp>
+        <p:nvSpPr>
+          <p:cNvPr id="14" name="Shape 11"/>
+          <p:cNvSpPr/>
+          <p:nvPr/>
+        </p:nvSpPr>
+        <p:spPr>
+          <a:xfrm>
+            <a:off x="6222492" y="896112"/>
+            <a:ext cx="5618988" cy="4526280"/>
+          </a:xfrm>
+          <a:prstGeom prst="roundRect">
+            <a:avLst>
+              <a:gd name="adj" fmla="val 2424"/>
+            </a:avLst>
+          </a:prstGeom>
+          <a:solidFill>
+            <a:srgbClr val="FFFFFF"/>
+          </a:solidFill>
+          <a:ln w="9525">
+            <a:solidFill>
+              <a:srgbClr val="E4EEE7"/>
+            </a:solidFill>
+            <a:prstDash val="solid"/>
+          </a:ln>
+          <a:effectLst>
+            <a:outerShdw sx="100000" sy="100000" kx="0" ky="0" algn="bl" rotWithShape="0" blurRad="101600" dist="25400" dir="16200000">
+              <a:srgbClr val="2F3E46">
+                <a:alpha val="10000"/>
+              </a:srgbClr>
+            </a:outerShdw>
+          </a:effectLst>
+        </p:spPr>
+      </p:sp>
+      <p:sp>
+        <p:nvSpPr>
+          <p:cNvPr id="15" name="Shape 12"/>
+          <p:cNvSpPr/>
+          <p:nvPr/>
+        </p:nvSpPr>
+        <p:spPr>
+          <a:xfrm>
+            <a:off x="6222492" y="896112"/>
+            <a:ext cx="5618988" cy="3657600"/>
+          </a:xfrm>
+          <a:prstGeom prst="rect">
+            <a:avLst/>
+          </a:prstGeom>
+          <a:solidFill>
+            <a:srgbClr val="D5E6DB"/>
+          </a:solidFill>
+          <a:ln w="12700">
+            <a:solidFill>
+              <a:srgbClr val="FFFFFF">
+                <a:alpha val="0"/>
+              </a:srgbClr>
+            </a:solidFill>
+            <a:prstDash val="solid"/>
+          </a:ln>
+        </p:spPr>
       </p:sp>
       <p:pic>
         <p:nvPicPr>
-          <p:cNvPr id="6" name="Image 1" descr="/workspace/inspecciones-calidad/app/public/assets/sello-resuelto.png">    </p:cNvPr>
+          <p:cNvPr id="16" name="Image 1" descr="preencoded.png">    </p:cNvPr>
           <p:cNvPicPr>
             <a:picLocks noChangeAspect="1"/>
           </p:cNvPicPr>
@@ -2538,23 +3456,168 @@
         </p:nvPicPr>
         <p:blipFill>
           <a:blip r:embed="rId2"/>
-          <a:stretch>
-            <a:fillRect/>
-          </a:stretch>
+          <a:srcRect l="0" r="0" t="0" b="0"/>
+          <a:stretch/>
         </p:blipFill>
         <p:spPr>
           <a:xfrm>
-            <a:off x="4617720" y="2377440"/>
-            <a:ext cx="960120" cy="914400"/>
+            <a:off x="6593586" y="896112"/>
+            <a:ext cx="4876800" cy="3657600"/>
           </a:xfrm>
           <a:prstGeom prst="rect">
             <a:avLst/>
           </a:prstGeom>
         </p:spPr>
       </p:pic>
+      <p:sp>
+        <p:nvSpPr>
+          <p:cNvPr id="17" name="Shape 13"/>
+          <p:cNvSpPr/>
+          <p:nvPr/>
+        </p:nvSpPr>
+        <p:spPr>
+          <a:xfrm>
+            <a:off x="10634472" y="987552"/>
+            <a:ext cx="1115568" cy="256032"/>
+          </a:xfrm>
+          <a:prstGeom prst="roundRect">
+            <a:avLst>
+              <a:gd name="adj" fmla="val 42857"/>
+            </a:avLst>
+          </a:prstGeom>
+          <a:solidFill>
+            <a:srgbClr val="03A64B"/>
+          </a:solidFill>
+          <a:ln w="12700">
+            <a:solidFill>
+              <a:srgbClr val="FFFFFF">
+                <a:alpha val="0"/>
+              </a:srgbClr>
+            </a:solidFill>
+            <a:prstDash val="solid"/>
+          </a:ln>
+        </p:spPr>
+      </p:sp>
+      <p:sp>
+        <p:nvSpPr>
+          <p:cNvPr id="18" name="Text 14"/>
+          <p:cNvSpPr/>
+          <p:nvPr/>
+        </p:nvSpPr>
+        <p:spPr>
+          <a:xfrm>
+            <a:off x="10634472" y="987552"/>
+            <a:ext cx="1115568" cy="256032"/>
+          </a:xfrm>
+          <a:prstGeom prst="rect">
+            <a:avLst/>
+          </a:prstGeom>
+          <a:noFill/>
+          <a:ln/>
+        </p:spPr>
+        <p:txBody>
+          <a:bodyPr wrap="square" lIns="0" tIns="0" rIns="0" bIns="0" rtlCol="0" anchor="ctr"/>
+          <a:lstStyle/>
+          <a:p>
+            <a:pPr algn="ctr" indent="0" marL="0">
+              <a:buNone/>
+            </a:pPr>
+            <a:r>
+              <a:rPr lang="en-US" sz="800" b="1" dirty="0">
+                <a:solidFill>
+                  <a:srgbClr val="FFFFFF"/>
+                </a:solidFill>
+                <a:latin typeface="Calibri" pitchFamily="34" charset="0"/>
+                <a:ea typeface="Calibri" pitchFamily="34" charset="-122"/>
+                <a:cs typeface="Calibri" pitchFamily="34" charset="-120"/>
+              </a:rPr>
+              <a:t>RESUELTO</a:t>
+            </a:r>
+            <a:endParaRPr lang="en-US" sz="800" dirty="0"/>
+          </a:p>
+        </p:txBody>
+      </p:sp>
+      <p:sp>
+        <p:nvSpPr>
+          <p:cNvPr id="19" name="Text 15"/>
+          <p:cNvSpPr/>
+          <p:nvPr/>
+        </p:nvSpPr>
+        <p:spPr>
+          <a:xfrm>
+            <a:off x="6350508" y="4645152"/>
+            <a:ext cx="5362956" cy="201168"/>
+          </a:xfrm>
+          <a:prstGeom prst="rect">
+            <a:avLst/>
+          </a:prstGeom>
+          <a:noFill/>
+          <a:ln/>
+        </p:spPr>
+        <p:txBody>
+          <a:bodyPr wrap="square" lIns="0" tIns="0" rIns="0" bIns="0" rtlCol="0" anchor="ctr"/>
+          <a:lstStyle/>
+          <a:p>
+            <a:pPr indent="0" marL="0">
+              <a:buNone/>
+            </a:pPr>
+            <a:r>
+              <a:rPr lang="en-US" sz="1000" b="1" dirty="0">
+                <a:solidFill>
+                  <a:srgbClr val="D9871A"/>
+                </a:solidFill>
+                <a:latin typeface="Calibri" pitchFamily="34" charset="0"/>
+                <a:ea typeface="Calibri" pitchFamily="34" charset="-122"/>
+                <a:cs typeface="Calibri" pitchFamily="34" charset="-120"/>
+              </a:rPr>
+              <a:t>J- · EB-06</a:t>
+            </a:r>
+            <a:endParaRPr lang="en-US" sz="1000" dirty="0"/>
+          </a:p>
+        </p:txBody>
+      </p:sp>
+      <p:sp>
+        <p:nvSpPr>
+          <p:cNvPr id="20" name="Text 16"/>
+          <p:cNvSpPr/>
+          <p:nvPr/>
+        </p:nvSpPr>
+        <p:spPr>
+          <a:xfrm>
+            <a:off x="6350508" y="4846320"/>
+            <a:ext cx="5362956" cy="384048"/>
+          </a:xfrm>
+          <a:prstGeom prst="rect">
+            <a:avLst/>
+          </a:prstGeom>
+          <a:noFill/>
+          <a:ln/>
+        </p:spPr>
+        <p:txBody>
+          <a:bodyPr wrap="square" lIns="0" tIns="0" rIns="0" bIns="0" rtlCol="0" anchor="t"/>
+          <a:lstStyle/>
+          <a:p>
+            <a:pPr indent="0" marL="0">
+              <a:buNone/>
+            </a:pPr>
+            <a:r>
+              <a:rPr lang="en-US" sz="1100" b="1" dirty="0">
+                <a:solidFill>
+                  <a:srgbClr val="2F3E46"/>
+                </a:solidFill>
+                <a:latin typeface="Calibri" pitchFamily="34" charset="0"/>
+                <a:ea typeface="Calibri" pitchFamily="34" charset="-122"/>
+                <a:cs typeface="Calibri" pitchFamily="34" charset="-120"/>
+              </a:rPr>
+              <a:t>REPARAR ESTANTERIA EB-06</a:t>
+            </a:r>
+            <a:endParaRPr lang="en-US" sz="1100" dirty="0"/>
+          </a:p>
+        </p:txBody>
+      </p:sp>
       <p:pic>
         <p:nvPicPr>
-          <p:cNvPr id="7" name="Image 2" descr="/workspace/inspecciones-calidad/samples/_tmp_V-VEST-02.png">    </p:cNvPr>
+          <p:cNvPr id="21" name="Image 2" descr="preencoded.png">    </p:cNvPr>
           <p:cNvPicPr>
             <a:picLocks noChangeAspect="1"/>
           </p:cNvPicPr>
@@ -2568,24 +3631,48 @@
         </p:blipFill>
         <p:spPr>
           <a:xfrm>
-            <a:off x="6492240" y="1051560"/>
-            <a:ext cx="5029200" cy="3657600"/>
+            <a:off x="0" y="5333695"/>
+            <a:ext cx="12191695" cy="1524305"/>
           </a:xfrm>
           <a:prstGeom prst="rect">
             <a:avLst/>
           </a:prstGeom>
         </p:spPr>
       </p:pic>
-      <p:sp>
-        <p:nvSpPr>
-          <p:cNvPr id="8" name="Text 3"/>
-          <p:cNvSpPr/>
-          <p:nvPr/>
-        </p:nvSpPr>
-        <p:spPr>
-          <a:xfrm>
-            <a:off x="6492240" y="2651760"/>
-            <a:ext cx="5029200" cy="457200"/>
+      <p:pic>
+        <p:nvPicPr>
+          <p:cNvPr id="22" name="Image 3" descr="preencoded.png">    </p:cNvPr>
+          <p:cNvPicPr>
+            <a:picLocks noChangeAspect="1"/>
+          </p:cNvPicPr>
+          <p:nvPr/>
+        </p:nvPicPr>
+        <p:blipFill>
+          <a:blip r:embed="rId4"/>
+          <a:stretch>
+            <a:fillRect/>
+          </a:stretch>
+        </p:blipFill>
+        <p:spPr>
+          <a:xfrm>
+            <a:off x="256032" y="5596128"/>
+            <a:ext cx="1024128" cy="1207008"/>
+          </a:xfrm>
+          <a:prstGeom prst="rect">
+            <a:avLst/>
+          </a:prstGeom>
+        </p:spPr>
+      </p:pic>
+      <p:sp>
+        <p:nvSpPr>
+          <p:cNvPr id="23" name="Text 17"/>
+          <p:cNvSpPr/>
+          <p:nvPr/>
+        </p:nvSpPr>
+        <p:spPr>
+          <a:xfrm>
+            <a:off x="1389888" y="6473952"/>
+            <a:ext cx="7589520" cy="256032"/>
           </a:xfrm>
           <a:prstGeom prst="rect">
             <a:avLst/>
@@ -2594,96 +3681,37 @@
           <a:ln/>
         </p:spPr>
         <p:txBody>
-          <a:bodyPr wrap="square" rtlCol="0" anchor="ctr"/>
-          <a:lstStyle/>
-          <a:p>
-            <a:pPr algn="ctr" indent="0" marL="0">
+          <a:bodyPr wrap="square" lIns="0" tIns="0" rIns="0" bIns="0" rtlCol="0" anchor="ctr"/>
+          <a:lstStyle/>
+          <a:p>
+            <a:pPr indent="0" marL="0">
               <a:buNone/>
             </a:pPr>
             <a:r>
-              <a:rPr lang="en-US" sz="2800" b="1" dirty="0">
+              <a:rPr lang="en-US" sz="1000" b="1" dirty="0">
                 <a:solidFill>
                   <a:srgbClr val="FFFFFF"/>
-                </a:solidFill>
-                <a:latin typeface="Arial" pitchFamily="34" charset="0"/>
-                <a:ea typeface="Arial" pitchFamily="34" charset="-122"/>
-                <a:cs typeface="Arial" pitchFamily="34" charset="-120"/>
-              </a:rPr>
-              <a:t>EJEMPLO</a:t>
-            </a:r>
-            <a:endParaRPr lang="en-US" sz="2800" dirty="0"/>
-          </a:p>
-        </p:txBody>
-      </p:sp>
-      <p:sp>
-        <p:nvSpPr>
-          <p:cNvPr id="9" name="Text 4"/>
-          <p:cNvSpPr/>
-          <p:nvPr/>
-        </p:nvSpPr>
-        <p:spPr>
-          <a:xfrm>
-            <a:off x="6492240" y="4846320"/>
-            <a:ext cx="5029200" cy="640080"/>
-          </a:xfrm>
-          <a:prstGeom prst="rect">
-            <a:avLst/>
-          </a:prstGeom>
-          <a:noFill/>
-          <a:ln/>
-        </p:spPr>
-        <p:txBody>
-          <a:bodyPr wrap="square" rtlCol="0" anchor="ctr"/>
-          <a:lstStyle/>
-          <a:p>
-            <a:pPr algn="ctr" indent="0" marL="0">
-              <a:buNone/>
-            </a:pPr>
-            <a:r>
-              <a:rPr lang="en-US" sz="1100" dirty="0">
-                <a:solidFill>
-                  <a:srgbClr val="000000"/>
                 </a:solidFill>
                 <a:latin typeface="Calibri" pitchFamily="34" charset="0"/>
                 <a:ea typeface="Calibri" pitchFamily="34" charset="-122"/>
                 <a:cs typeface="Calibri" pitchFamily="34" charset="-120"/>
               </a:rPr>
-              <a:t>EJEMPLO — BANCO SUELTO — VESTUARIO 02</a:t>
-            </a:r>
-            <a:endParaRPr lang="en-US" sz="1100" dirty="0"/>
-          </a:p>
-        </p:txBody>
-      </p:sp>
-      <p:sp>
-        <p:nvSpPr>
-          <p:cNvPr id="10" name="Shape 5"/>
-          <p:cNvSpPr/>
-          <p:nvPr/>
-        </p:nvSpPr>
-        <p:spPr>
-          <a:xfrm>
-            <a:off x="6629400" y="1188720"/>
-            <a:ext cx="1463040" cy="347472"/>
-          </a:xfrm>
-          <a:prstGeom prst="roundRect">
-            <a:avLst/>
-          </a:prstGeom>
-          <a:solidFill>
-            <a:srgbClr val="ED7D31"/>
-          </a:solidFill>
-          <a:ln/>
-        </p:spPr>
-      </p:sp>
-      <p:sp>
-        <p:nvSpPr>
-          <p:cNvPr id="11" name="Text 6"/>
-          <p:cNvSpPr/>
-          <p:nvPr/>
-        </p:nvSpPr>
-        <p:spPr>
-          <a:xfrm>
-            <a:off x="6629400" y="1188720"/>
-            <a:ext cx="1463040" cy="347472"/>
+              <a:t>Inspecciones calidad · Refresco Iberia · Planta Alcolea</a:t>
+            </a:r>
+            <a:endParaRPr lang="en-US" sz="1000" dirty="0"/>
+          </a:p>
+        </p:txBody>
+      </p:sp>
+      <p:sp>
+        <p:nvSpPr>
+          <p:cNvPr id="24" name="Text 18"/>
+          <p:cNvSpPr/>
+          <p:nvPr/>
+        </p:nvSpPr>
+        <p:spPr>
+          <a:xfrm>
+            <a:off x="9281160" y="6364224"/>
+            <a:ext cx="2651760" cy="384048"/>
           </a:xfrm>
           <a:prstGeom prst="rect">
             <a:avLst/>
@@ -2692,21 +3720,63 @@
           <a:ln/>
         </p:spPr>
         <p:txBody>
-          <a:bodyPr wrap="square" rtlCol="0" anchor="ctr"/>
-          <a:lstStyle/>
-          <a:p>
-            <a:pPr algn="ctr" indent="0" marL="0">
+          <a:bodyPr wrap="square" lIns="0" tIns="0" rIns="0" bIns="0" rtlCol="0" anchor="ctr"/>
+          <a:lstStyle/>
+          <a:p>
+            <a:pPr algn="r" indent="0" marL="0">
               <a:buNone/>
             </a:pPr>
             <a:r>
-              <a:rPr lang="en-US" sz="1100" b="1" dirty="0">
+              <a:rPr lang="en-US" sz="1800" b="1" dirty="0">
                 <a:solidFill>
                   <a:srgbClr val="FFFFFF"/>
                 </a:solidFill>
+                <a:latin typeface="Calibri" pitchFamily="34" charset="0"/>
+                <a:ea typeface="Calibri" pitchFamily="34" charset="-122"/>
+                <a:cs typeface="Calibri" pitchFamily="34" charset="-120"/>
               </a:rPr>
-              <a:t>PENDIENTE</a:t>
-            </a:r>
-            <a:endParaRPr lang="en-US" sz="1100" dirty="0"/>
+              <a:t>Refresco</a:t>
+            </a:r>
+            <a:endParaRPr lang="en-US" sz="1800" dirty="0"/>
+          </a:p>
+        </p:txBody>
+      </p:sp>
+      <p:sp>
+        <p:nvSpPr>
+          <p:cNvPr id="25" name="Text 19"/>
+          <p:cNvSpPr/>
+          <p:nvPr/>
+        </p:nvSpPr>
+        <p:spPr>
+          <a:xfrm>
+            <a:off x="54864" y="6492240"/>
+            <a:ext cx="201168" cy="201168"/>
+          </a:xfrm>
+          <a:prstGeom prst="rect">
+            <a:avLst/>
+          </a:prstGeom>
+          <a:noFill/>
+          <a:ln/>
+        </p:spPr>
+        <p:txBody>
+          <a:bodyPr wrap="square" lIns="0" tIns="0" rIns="0" bIns="0" rtlCol="0" anchor="ctr"/>
+          <a:lstStyle/>
+          <a:p>
+            <a:pPr algn="l" indent="0" marL="0">
+              <a:buNone/>
+            </a:pPr>
+            <a:r>
+              <a:rPr lang="en-US" sz="900" b="1" dirty="0">
+                <a:solidFill>
+                  <a:srgbClr val="FFFFFF"/>
+                </a:solidFill>
+                <a:latin typeface="Calibri" pitchFamily="34" charset="0"/>
+                <a:ea typeface="Calibri" pitchFamily="34" charset="-122"/>
+                <a:cs typeface="Calibri" pitchFamily="34" charset="-120"/>
+              </a:rPr>
+              <a:t>5</a:t>
+            </a:r>
+            <a:endParaRPr lang="en-US" sz="900" dirty="0"/>
           </a:p>
         </p:txBody>
       </p:sp>

</xml_diff>

<commit_message>
Trim logo frame and wrap cover title to match v3 mocks
Crop the black screenshot border from the Refresco wordmark and constrain the cover title so PPTX/PDF wrap to two lines like the approved portada.

Co-authored-by: jorgefausto0074-pc <jorgefausto0074-pc@users.noreply.github.com>
</commit_message>
<xml_diff>
--- a/samples/informe-ejemplo-alcolea.pptx
+++ b/samples/informe-ejemplo-alcolea.pptx
@@ -1363,8 +1363,8 @@
         </p:blipFill>
         <p:spPr>
           <a:xfrm>
-            <a:off x="1190695" y="1280160"/>
-            <a:ext cx="1376793" cy="841248"/>
+            <a:off x="1181757" y="1280160"/>
+            <a:ext cx="1394670" cy="841248"/>
           </a:xfrm>
           <a:prstGeom prst="rect">
             <a:avLst/>
@@ -1418,8 +1418,8 @@
         </p:nvSpPr>
         <p:spPr>
           <a:xfrm>
-            <a:off x="713232" y="2852928"/>
-            <a:ext cx="6949440" cy="1234440"/>
+            <a:off x="713232" y="2816352"/>
+            <a:ext cx="5989320" cy="1325880"/>
           </a:xfrm>
           <a:prstGeom prst="rect">
             <a:avLst/>
@@ -1435,7 +1435,7 @@
               <a:buNone/>
             </a:pPr>
             <a:r>
-              <a:rPr lang="en-US" sz="2800" b="1" dirty="0">
+              <a:rPr lang="en-US" sz="3000" b="1" dirty="0">
                 <a:solidFill>
                   <a:srgbClr val="03A64B"/>
                 </a:solidFill>
@@ -1445,7 +1445,7 @@
               </a:rPr>
               <a:t>INSPECCION INCIDENCIAS CALIDAD</a:t>
             </a:r>
-            <a:endParaRPr lang="en-US" sz="2800" dirty="0"/>
+            <a:endParaRPr lang="en-US" sz="3000" dirty="0"/>
           </a:p>
         </p:txBody>
       </p:sp>

</xml_diff>